<commit_message>
fix: fix upload to KB problems
</commit_message>
<xml_diff>
--- a/docs/Atelier_Pratique_Pipeline_STM32Cube.pptx
+++ b/docs/Atelier_Pratique_Pipeline_STM32Cube.pptx
@@ -4,6 +4,9 @@
   <p:sldMasterIdLst>
     <p:sldMasterId id="2147483648" r:id="rId1"/>
   </p:sldMasterIdLst>
+  <p:notesMasterIdLst>
+    <p:notesMasterId r:id="rId33"/>
+  </p:notesMasterIdLst>
   <p:sldIdLst>
     <p:sldId id="256" r:id="rId2"/>
     <p:sldId id="257" r:id="rId3"/>
@@ -36,8 +39,9 @@
     <p:sldId id="284" r:id="rId30"/>
     <p:sldId id="285" r:id="rId31"/>
     <p:sldId id="286" r:id="rId32"/>
-    <p:sldId id="287" r:id="rId33"/>
-    <p:sldId id="288" r:id="rId34"/>
+    <p:sldId id="287" r:id="rId40"/>
+    <p:sldId id="288" r:id="rId41"/>
+    <p:sldId id="289" r:id="rId42"/>
   </p:sldIdLst>
   <p:sldSz cx="9144000" cy="6858000" type="screen4x3"/>
   <p:notesSz cx="6858000" cy="9144000"/>
@@ -158,7 +162,7 @@
 <file path=ppt/revisionInfo.xml><?xml version="1.0" encoding="utf-8"?>
 <p1510:revInfo xmlns:a="http://schemas.openxmlformats.org/drawingml/2006/main" xmlns:r="http://schemas.openxmlformats.org/officeDocument/2006/relationships" xmlns:p1510="http://schemas.microsoft.com/office/powerpoint/2015/10/main">
   <p1510:revLst>
-    <p1510:client id="{AC1A9B47-969F-4FB4-9DC4-5D1C1621205B}" v="4" dt="2026-06-25T16:04:04.931"/>
+    <p1510:client id="{AC1A9B47-969F-4FB4-9DC4-5D1C1621205B}" v="5" dt="2026-06-26T08:26:09.134"/>
   </p1510:revLst>
 </p1510:revInfo>
 </file>
@@ -167,8 +171,8 @@
 <pc:chgInfo xmlns:a="http://schemas.openxmlformats.org/drawingml/2006/main" xmlns:r="http://schemas.openxmlformats.org/officeDocument/2006/relationships" xmlns:ac="http://schemas.microsoft.com/office/drawing/2013/main/command" xmlns:pc="http://schemas.microsoft.com/office/powerpoint/2013/main/command">
   <pc:docChgLst>
     <pc:chgData name="Abir GHARBI" userId="ef92528f-00ab-4d87-966c-386bca485bd0" providerId="ADAL" clId="{F3D16DED-CAA7-4BF5-81E4-89DEDE7057F7}"/>
-    <pc:docChg chg="undo custSel modSld">
-      <pc:chgData name="Abir GHARBI" userId="ef92528f-00ab-4d87-966c-386bca485bd0" providerId="ADAL" clId="{F3D16DED-CAA7-4BF5-81E4-89DEDE7057F7}" dt="2026-06-25T16:05:30.912" v="70" actId="404"/>
+    <pc:docChg chg="undo custSel delSld modSld">
+      <pc:chgData name="Abir GHARBI" userId="ef92528f-00ab-4d87-966c-386bca485bd0" providerId="ADAL" clId="{F3D16DED-CAA7-4BF5-81E4-89DEDE7057F7}" dt="2026-06-26T08:31:16.831" v="93" actId="47"/>
       <pc:docMkLst>
         <pc:docMk/>
       </pc:docMkLst>
@@ -339,8 +343,8 @@
           </ac:spMkLst>
         </pc:spChg>
       </pc:sldChg>
-      <pc:sldChg chg="modSp mod">
-        <pc:chgData name="Abir GHARBI" userId="ef92528f-00ab-4d87-966c-386bca485bd0" providerId="ADAL" clId="{F3D16DED-CAA7-4BF5-81E4-89DEDE7057F7}" dt="2026-06-25T16:05:14.708" v="67" actId="404"/>
+      <pc:sldChg chg="modSp del mod">
+        <pc:chgData name="Abir GHARBI" userId="ef92528f-00ab-4d87-966c-386bca485bd0" providerId="ADAL" clId="{F3D16DED-CAA7-4BF5-81E4-89DEDE7057F7}" dt="2026-06-26T08:31:16.831" v="93" actId="47"/>
         <pc:sldMkLst>
           <pc:docMk/>
           <pc:sldMk cId="0" sldId="287"/>
@@ -362,8 +366,8 @@
           </ac:spMkLst>
         </pc:spChg>
       </pc:sldChg>
-      <pc:sldChg chg="modSp mod">
-        <pc:chgData name="Abir GHARBI" userId="ef92528f-00ab-4d87-966c-386bca485bd0" providerId="ADAL" clId="{F3D16DED-CAA7-4BF5-81E4-89DEDE7057F7}" dt="2026-06-25T16:05:30.912" v="70" actId="404"/>
+      <pc:sldChg chg="modSp del mod">
+        <pc:chgData name="Abir GHARBI" userId="ef92528f-00ab-4d87-966c-386bca485bd0" providerId="ADAL" clId="{F3D16DED-CAA7-4BF5-81E4-89DEDE7057F7}" dt="2026-06-26T08:31:16.831" v="93" actId="47"/>
         <pc:sldMkLst>
           <pc:docMk/>
           <pc:sldMk cId="0" sldId="288"/>
@@ -385,9 +389,480 @@
           </ac:spMkLst>
         </pc:spChg>
       </pc:sldChg>
+      <pc:sldChg chg="modSp del mod">
+        <pc:chgData name="Abir GHARBI" userId="ef92528f-00ab-4d87-966c-386bca485bd0" providerId="ADAL" clId="{F3D16DED-CAA7-4BF5-81E4-89DEDE7057F7}" dt="2026-06-26T08:31:16.831" v="93" actId="47"/>
+        <pc:sldMkLst>
+          <pc:docMk/>
+          <pc:sldMk cId="0" sldId="289"/>
+        </pc:sldMkLst>
+        <pc:spChg chg="mod">
+          <ac:chgData name="Abir GHARBI" userId="ef92528f-00ab-4d87-966c-386bca485bd0" providerId="ADAL" clId="{F3D16DED-CAA7-4BF5-81E4-89DEDE7057F7}" dt="2026-06-26T08:26:44.751" v="87" actId="20577"/>
+          <ac:spMkLst>
+            <pc:docMk/>
+            <pc:sldMk cId="0" sldId="289"/>
+            <ac:spMk id="3" creationId="{00000000-0000-0000-0000-000000000000}"/>
+          </ac:spMkLst>
+        </pc:spChg>
+      </pc:sldChg>
+      <pc:sldChg chg="modSp del mod">
+        <pc:chgData name="Abir GHARBI" userId="ef92528f-00ab-4d87-966c-386bca485bd0" providerId="ADAL" clId="{F3D16DED-CAA7-4BF5-81E4-89DEDE7057F7}" dt="2026-06-26T08:31:16.831" v="93" actId="47"/>
+        <pc:sldMkLst>
+          <pc:docMk/>
+          <pc:sldMk cId="0" sldId="290"/>
+        </pc:sldMkLst>
+        <pc:spChg chg="mod">
+          <ac:chgData name="Abir GHARBI" userId="ef92528f-00ab-4d87-966c-386bca485bd0" providerId="ADAL" clId="{F3D16DED-CAA7-4BF5-81E4-89DEDE7057F7}" dt="2026-06-26T08:26:09.370" v="78" actId="27636"/>
+          <ac:spMkLst>
+            <pc:docMk/>
+            <pc:sldMk cId="0" sldId="290"/>
+            <ac:spMk id="2" creationId="{00000000-0000-0000-0000-000000000000}"/>
+          </ac:spMkLst>
+        </pc:spChg>
+        <pc:spChg chg="mod">
+          <ac:chgData name="Abir GHARBI" userId="ef92528f-00ab-4d87-966c-386bca485bd0" providerId="ADAL" clId="{F3D16DED-CAA7-4BF5-81E4-89DEDE7057F7}" dt="2026-06-26T08:28:33.048" v="92" actId="20577"/>
+          <ac:spMkLst>
+            <pc:docMk/>
+            <pc:sldMk cId="0" sldId="290"/>
+            <ac:spMk id="3" creationId="{00000000-0000-0000-0000-000000000000}"/>
+          </ac:spMkLst>
+        </pc:spChg>
+      </pc:sldChg>
     </pc:docChg>
   </pc:docChgLst>
 </pc:chgInfo>
+</file>
+
+<file path=ppt/notesMasters/notesMaster1.xml><?xml version="1.0" encoding="utf-8"?>
+<p:notesMaster xmlns:a="http://schemas.openxmlformats.org/drawingml/2006/main" xmlns:r="http://schemas.openxmlformats.org/officeDocument/2006/relationships" xmlns:p="http://schemas.openxmlformats.org/presentationml/2006/main">
+  <p:cSld>
+    <p:bg>
+      <p:bgRef idx="1001">
+        <a:schemeClr val="bg1"/>
+      </p:bgRef>
+    </p:bg>
+    <p:spTree>
+      <p:nvGrpSpPr>
+        <p:cNvPr id="1" name=""/>
+        <p:cNvGrpSpPr/>
+        <p:nvPr/>
+      </p:nvGrpSpPr>
+      <p:grpSpPr>
+        <a:xfrm>
+          <a:off x="0" y="0"/>
+          <a:ext cx="0" cy="0"/>
+          <a:chOff x="0" y="0"/>
+          <a:chExt cx="0" cy="0"/>
+        </a:xfrm>
+      </p:grpSpPr>
+      <p:sp>
+        <p:nvSpPr>
+          <p:cNvPr id="2" name="Header Placeholder 1"/>
+          <p:cNvSpPr>
+            <a:spLocks noGrp="1"/>
+          </p:cNvSpPr>
+          <p:nvPr>
+            <p:ph type="hdr" sz="quarter"/>
+          </p:nvPr>
+        </p:nvSpPr>
+        <p:spPr>
+          <a:xfrm>
+            <a:off x="0" y="0"/>
+            <a:ext cx="2971800" cy="458788"/>
+          </a:xfrm>
+          <a:prstGeom prst="rect">
+            <a:avLst/>
+          </a:prstGeom>
+        </p:spPr>
+        <p:txBody>
+          <a:bodyPr vert="horz" lIns="91440" tIns="45720" rIns="91440" bIns="45720" rtlCol="0"/>
+          <a:lstStyle>
+            <a:lvl1pPr algn="l">
+              <a:defRPr sz="1200"/>
+            </a:lvl1pPr>
+          </a:lstStyle>
+          <a:p>
+            <a:endParaRPr lang="en-US"/>
+          </a:p>
+        </p:txBody>
+      </p:sp>
+      <p:sp>
+        <p:nvSpPr>
+          <p:cNvPr id="3" name="Date Placeholder 2"/>
+          <p:cNvSpPr>
+            <a:spLocks noGrp="1"/>
+          </p:cNvSpPr>
+          <p:nvPr>
+            <p:ph type="dt" idx="1"/>
+          </p:nvPr>
+        </p:nvSpPr>
+        <p:spPr>
+          <a:xfrm>
+            <a:off x="3884613" y="0"/>
+            <a:ext cx="2971800" cy="458788"/>
+          </a:xfrm>
+          <a:prstGeom prst="rect">
+            <a:avLst/>
+          </a:prstGeom>
+        </p:spPr>
+        <p:txBody>
+          <a:bodyPr vert="horz" lIns="91440" tIns="45720" rIns="91440" bIns="45720" rtlCol="0"/>
+          <a:lstStyle>
+            <a:lvl1pPr algn="r">
+              <a:defRPr sz="1200"/>
+            </a:lvl1pPr>
+          </a:lstStyle>
+          <a:p>
+            <a:fld id="{C1CB68D9-53B7-4E6D-B3E5-7C1855B8A422}" type="datetimeFigureOut">
+              <a:rPr lang="en-US" smtClean="0"/>
+              <a:t>6/26/2026</a:t>
+            </a:fld>
+            <a:endParaRPr lang="en-US"/>
+          </a:p>
+        </p:txBody>
+      </p:sp>
+      <p:sp>
+        <p:nvSpPr>
+          <p:cNvPr id="4" name="Slide Image Placeholder 3"/>
+          <p:cNvSpPr>
+            <a:spLocks noGrp="1" noRot="1" noChangeAspect="1"/>
+          </p:cNvSpPr>
+          <p:nvPr>
+            <p:ph type="sldImg" idx="2"/>
+          </p:nvPr>
+        </p:nvSpPr>
+        <p:spPr>
+          <a:xfrm>
+            <a:off x="1371600" y="1143000"/>
+            <a:ext cx="4114800" cy="3086100"/>
+          </a:xfrm>
+          <a:prstGeom prst="rect">
+            <a:avLst/>
+          </a:prstGeom>
+          <a:noFill/>
+          <a:ln w="12700">
+            <a:solidFill>
+              <a:prstClr val="black"/>
+            </a:solidFill>
+          </a:ln>
+        </p:spPr>
+        <p:txBody>
+          <a:bodyPr vert="horz" lIns="91440" tIns="45720" rIns="91440" bIns="45720" rtlCol="0" anchor="ctr"/>
+          <a:lstStyle/>
+          <a:p>
+            <a:endParaRPr lang="en-US"/>
+          </a:p>
+        </p:txBody>
+      </p:sp>
+      <p:sp>
+        <p:nvSpPr>
+          <p:cNvPr id="5" name="Notes Placeholder 4"/>
+          <p:cNvSpPr>
+            <a:spLocks noGrp="1"/>
+          </p:cNvSpPr>
+          <p:nvPr>
+            <p:ph type="body" sz="quarter" idx="3"/>
+          </p:nvPr>
+        </p:nvSpPr>
+        <p:spPr>
+          <a:xfrm>
+            <a:off x="685800" y="4400550"/>
+            <a:ext cx="5486400" cy="3600450"/>
+          </a:xfrm>
+          <a:prstGeom prst="rect">
+            <a:avLst/>
+          </a:prstGeom>
+        </p:spPr>
+        <p:txBody>
+          <a:bodyPr vert="horz" lIns="91440" tIns="45720" rIns="91440" bIns="45720" rtlCol="0"/>
+          <a:lstStyle/>
+          <a:p>
+            <a:pPr lvl="0"/>
+            <a:r>
+              <a:rPr lang="en-US"/>
+              <a:t>Click to edit Master text styles</a:t>
+            </a:r>
+          </a:p>
+          <a:p>
+            <a:pPr lvl="1"/>
+            <a:r>
+              <a:rPr lang="en-US"/>
+              <a:t>Second level</a:t>
+            </a:r>
+          </a:p>
+          <a:p>
+            <a:pPr lvl="2"/>
+            <a:r>
+              <a:rPr lang="en-US"/>
+              <a:t>Third level</a:t>
+            </a:r>
+          </a:p>
+          <a:p>
+            <a:pPr lvl="3"/>
+            <a:r>
+              <a:rPr lang="en-US"/>
+              <a:t>Fourth level</a:t>
+            </a:r>
+          </a:p>
+          <a:p>
+            <a:pPr lvl="4"/>
+            <a:r>
+              <a:rPr lang="en-US"/>
+              <a:t>Fifth level</a:t>
+            </a:r>
+          </a:p>
+        </p:txBody>
+      </p:sp>
+      <p:sp>
+        <p:nvSpPr>
+          <p:cNvPr id="6" name="Footer Placeholder 5"/>
+          <p:cNvSpPr>
+            <a:spLocks noGrp="1"/>
+          </p:cNvSpPr>
+          <p:nvPr>
+            <p:ph type="ftr" sz="quarter" idx="4"/>
+          </p:nvPr>
+        </p:nvSpPr>
+        <p:spPr>
+          <a:xfrm>
+            <a:off x="0" y="8685213"/>
+            <a:ext cx="2971800" cy="458787"/>
+          </a:xfrm>
+          <a:prstGeom prst="rect">
+            <a:avLst/>
+          </a:prstGeom>
+        </p:spPr>
+        <p:txBody>
+          <a:bodyPr vert="horz" lIns="91440" tIns="45720" rIns="91440" bIns="45720" rtlCol="0" anchor="b"/>
+          <a:lstStyle>
+            <a:lvl1pPr algn="l">
+              <a:defRPr sz="1200"/>
+            </a:lvl1pPr>
+          </a:lstStyle>
+          <a:p>
+            <a:endParaRPr lang="en-US"/>
+          </a:p>
+        </p:txBody>
+      </p:sp>
+      <p:sp>
+        <p:nvSpPr>
+          <p:cNvPr id="7" name="Slide Number Placeholder 6"/>
+          <p:cNvSpPr>
+            <a:spLocks noGrp="1"/>
+          </p:cNvSpPr>
+          <p:nvPr>
+            <p:ph type="sldNum" sz="quarter" idx="5"/>
+          </p:nvPr>
+        </p:nvSpPr>
+        <p:spPr>
+          <a:xfrm>
+            <a:off x="3884613" y="8685213"/>
+            <a:ext cx="2971800" cy="458787"/>
+          </a:xfrm>
+          <a:prstGeom prst="rect">
+            <a:avLst/>
+          </a:prstGeom>
+        </p:spPr>
+        <p:txBody>
+          <a:bodyPr vert="horz" lIns="91440" tIns="45720" rIns="91440" bIns="45720" rtlCol="0" anchor="b"/>
+          <a:lstStyle>
+            <a:lvl1pPr algn="r">
+              <a:defRPr sz="1200"/>
+            </a:lvl1pPr>
+          </a:lstStyle>
+          <a:p>
+            <a:fld id="{D5679A62-C517-4E87-AAEF-00359559152F}" type="slidenum">
+              <a:rPr lang="en-US" smtClean="0"/>
+              <a:t>‹#›</a:t>
+            </a:fld>
+            <a:endParaRPr lang="en-US"/>
+          </a:p>
+        </p:txBody>
+      </p:sp>
+    </p:spTree>
+    <p:extLst>
+      <p:ext uri="{BB962C8B-B14F-4D97-AF65-F5344CB8AC3E}">
+        <p14:creationId xmlns:p14="http://schemas.microsoft.com/office/powerpoint/2010/main" val="1433206895"/>
+      </p:ext>
+    </p:extLst>
+  </p:cSld>
+  <p:clrMap bg1="lt1" tx1="dk1" bg2="lt2" tx2="dk2" accent1="accent1" accent2="accent2" accent3="accent3" accent4="accent4" accent5="accent5" accent6="accent6" hlink="hlink" folHlink="folHlink"/>
+  <p:notesStyle>
+    <a:lvl1pPr marL="0" algn="l" defTabSz="914400" rtl="0" eaLnBrk="1" latinLnBrk="0" hangingPunct="1">
+      <a:defRPr sz="1200" kern="1200">
+        <a:solidFill>
+          <a:schemeClr val="tx1"/>
+        </a:solidFill>
+        <a:latin typeface="+mn-lt"/>
+        <a:ea typeface="+mn-ea"/>
+        <a:cs typeface="+mn-cs"/>
+      </a:defRPr>
+    </a:lvl1pPr>
+    <a:lvl2pPr marL="457200" algn="l" defTabSz="914400" rtl="0" eaLnBrk="1" latinLnBrk="0" hangingPunct="1">
+      <a:defRPr sz="1200" kern="1200">
+        <a:solidFill>
+          <a:schemeClr val="tx1"/>
+        </a:solidFill>
+        <a:latin typeface="+mn-lt"/>
+        <a:ea typeface="+mn-ea"/>
+        <a:cs typeface="+mn-cs"/>
+      </a:defRPr>
+    </a:lvl2pPr>
+    <a:lvl3pPr marL="914400" algn="l" defTabSz="914400" rtl="0" eaLnBrk="1" latinLnBrk="0" hangingPunct="1">
+      <a:defRPr sz="1200" kern="1200">
+        <a:solidFill>
+          <a:schemeClr val="tx1"/>
+        </a:solidFill>
+        <a:latin typeface="+mn-lt"/>
+        <a:ea typeface="+mn-ea"/>
+        <a:cs typeface="+mn-cs"/>
+      </a:defRPr>
+    </a:lvl3pPr>
+    <a:lvl4pPr marL="1371600" algn="l" defTabSz="914400" rtl="0" eaLnBrk="1" latinLnBrk="0" hangingPunct="1">
+      <a:defRPr sz="1200" kern="1200">
+        <a:solidFill>
+          <a:schemeClr val="tx1"/>
+        </a:solidFill>
+        <a:latin typeface="+mn-lt"/>
+        <a:ea typeface="+mn-ea"/>
+        <a:cs typeface="+mn-cs"/>
+      </a:defRPr>
+    </a:lvl4pPr>
+    <a:lvl5pPr marL="1828800" algn="l" defTabSz="914400" rtl="0" eaLnBrk="1" latinLnBrk="0" hangingPunct="1">
+      <a:defRPr sz="1200" kern="1200">
+        <a:solidFill>
+          <a:schemeClr val="tx1"/>
+        </a:solidFill>
+        <a:latin typeface="+mn-lt"/>
+        <a:ea typeface="+mn-ea"/>
+        <a:cs typeface="+mn-cs"/>
+      </a:defRPr>
+    </a:lvl5pPr>
+    <a:lvl6pPr marL="2286000" algn="l" defTabSz="914400" rtl="0" eaLnBrk="1" latinLnBrk="0" hangingPunct="1">
+      <a:defRPr sz="1200" kern="1200">
+        <a:solidFill>
+          <a:schemeClr val="tx1"/>
+        </a:solidFill>
+        <a:latin typeface="+mn-lt"/>
+        <a:ea typeface="+mn-ea"/>
+        <a:cs typeface="+mn-cs"/>
+      </a:defRPr>
+    </a:lvl6pPr>
+    <a:lvl7pPr marL="2743200" algn="l" defTabSz="914400" rtl="0" eaLnBrk="1" latinLnBrk="0" hangingPunct="1">
+      <a:defRPr sz="1200" kern="1200">
+        <a:solidFill>
+          <a:schemeClr val="tx1"/>
+        </a:solidFill>
+        <a:latin typeface="+mn-lt"/>
+        <a:ea typeface="+mn-ea"/>
+        <a:cs typeface="+mn-cs"/>
+      </a:defRPr>
+    </a:lvl7pPr>
+    <a:lvl8pPr marL="3200400" algn="l" defTabSz="914400" rtl="0" eaLnBrk="1" latinLnBrk="0" hangingPunct="1">
+      <a:defRPr sz="1200" kern="1200">
+        <a:solidFill>
+          <a:schemeClr val="tx1"/>
+        </a:solidFill>
+        <a:latin typeface="+mn-lt"/>
+        <a:ea typeface="+mn-ea"/>
+        <a:cs typeface="+mn-cs"/>
+      </a:defRPr>
+    </a:lvl8pPr>
+    <a:lvl9pPr marL="3657600" algn="l" defTabSz="914400" rtl="0" eaLnBrk="1" latinLnBrk="0" hangingPunct="1">
+      <a:defRPr sz="1200" kern="1200">
+        <a:solidFill>
+          <a:schemeClr val="tx1"/>
+        </a:solidFill>
+        <a:latin typeface="+mn-lt"/>
+        <a:ea typeface="+mn-ea"/>
+        <a:cs typeface="+mn-cs"/>
+      </a:defRPr>
+    </a:lvl9pPr>
+  </p:notesStyle>
+</p:notesMaster>
+</file>
+
+<file path=ppt/notesSlides/notesSlide1.xml><?xml version="1.0" encoding="utf-8"?>
+<p:notes xmlns:a="http://schemas.openxmlformats.org/drawingml/2006/main" xmlns:r="http://schemas.openxmlformats.org/officeDocument/2006/relationships" xmlns:p="http://schemas.openxmlformats.org/presentationml/2006/main">
+  <p:cSld>
+    <p:spTree>
+      <p:nvGrpSpPr>
+        <p:cNvPr id="1" name=""/>
+        <p:cNvGrpSpPr/>
+        <p:nvPr/>
+      </p:nvGrpSpPr>
+      <p:grpSpPr>
+        <a:xfrm>
+          <a:off x="0" y="0"/>
+          <a:ext cx="0" cy="0"/>
+          <a:chOff x="0" y="0"/>
+          <a:chExt cx="0" cy="0"/>
+        </a:xfrm>
+      </p:grpSpPr>
+      <p:sp>
+        <p:nvSpPr>
+          <p:cNvPr id="2" name="Slide Image Placeholder 1"/>
+          <p:cNvSpPr>
+            <a:spLocks noGrp="1" noRot="1" noChangeAspect="1"/>
+          </p:cNvSpPr>
+          <p:nvPr>
+            <p:ph type="sldImg"/>
+          </p:nvPr>
+        </p:nvSpPr>
+        <p:spPr/>
+      </p:sp>
+      <p:sp>
+        <p:nvSpPr>
+          <p:cNvPr id="3" name="Notes Placeholder 2"/>
+          <p:cNvSpPr>
+            <a:spLocks noGrp="1"/>
+          </p:cNvSpPr>
+          <p:nvPr>
+            <p:ph type="body" idx="1"/>
+          </p:nvPr>
+        </p:nvSpPr>
+        <p:spPr/>
+        <p:txBody>
+          <a:bodyPr/>
+          <a:lstStyle/>
+          <a:p>
+            <a:endParaRPr lang="en-US" dirty="0"/>
+          </a:p>
+        </p:txBody>
+      </p:sp>
+      <p:sp>
+        <p:nvSpPr>
+          <p:cNvPr id="4" name="Slide Number Placeholder 3"/>
+          <p:cNvSpPr>
+            <a:spLocks noGrp="1"/>
+          </p:cNvSpPr>
+          <p:nvPr>
+            <p:ph type="sldNum" sz="quarter" idx="5"/>
+          </p:nvPr>
+        </p:nvSpPr>
+        <p:spPr/>
+        <p:txBody>
+          <a:bodyPr/>
+          <a:lstStyle/>
+          <a:p>
+            <a:fld id="{D5679A62-C517-4E87-AAEF-00359559152F}" type="slidenum">
+              <a:rPr lang="en-US" smtClean="0"/>
+              <a:t>31</a:t>
+            </a:fld>
+            <a:endParaRPr lang="en-US"/>
+          </a:p>
+        </p:txBody>
+      </p:sp>
+    </p:spTree>
+    <p:extLst>
+      <p:ext uri="{BB962C8B-B14F-4D97-AF65-F5344CB8AC3E}">
+        <p14:creationId xmlns:p14="http://schemas.microsoft.com/office/powerpoint/2010/main" val="1326835225"/>
+      </p:ext>
+    </p:extLst>
+  </p:cSld>
+  <p:clrMapOvr>
+    <a:masterClrMapping/>
+  </p:clrMapOvr>
+</p:notes>
 </file>
 
 <file path=ppt/slideLayouts/slideLayout1.xml><?xml version="1.0" encoding="utf-8"?>
@@ -569,7 +1044,7 @@
           <a:p>
             <a:fld id="{5BCAD085-E8A6-8845-BD4E-CB4CCA059FC4}" type="datetimeFigureOut">
               <a:rPr lang="en-US" smtClean="0"/>
-              <a:t>6/25/2026</a:t>
+              <a:t>6/26/2026</a:t>
             </a:fld>
             <a:endParaRPr lang="en-US"/>
           </a:p>
@@ -737,7 +1212,7 @@
           <a:p>
             <a:fld id="{5BCAD085-E8A6-8845-BD4E-CB4CCA059FC4}" type="datetimeFigureOut">
               <a:rPr lang="en-US" smtClean="0"/>
-              <a:t>6/25/2026</a:t>
+              <a:t>6/26/2026</a:t>
             </a:fld>
             <a:endParaRPr lang="en-US"/>
           </a:p>
@@ -915,7 +1390,7 @@
           <a:p>
             <a:fld id="{5BCAD085-E8A6-8845-BD4E-CB4CCA059FC4}" type="datetimeFigureOut">
               <a:rPr lang="en-US" smtClean="0"/>
-              <a:t>6/25/2026</a:t>
+              <a:t>6/26/2026</a:t>
             </a:fld>
             <a:endParaRPr lang="en-US"/>
           </a:p>
@@ -1083,7 +1558,7 @@
           <a:p>
             <a:fld id="{5BCAD085-E8A6-8845-BD4E-CB4CCA059FC4}" type="datetimeFigureOut">
               <a:rPr lang="en-US" smtClean="0"/>
-              <a:t>6/25/2026</a:t>
+              <a:t>6/26/2026</a:t>
             </a:fld>
             <a:endParaRPr lang="en-US"/>
           </a:p>
@@ -1328,7 +1803,7 @@
           <a:p>
             <a:fld id="{5BCAD085-E8A6-8845-BD4E-CB4CCA059FC4}" type="datetimeFigureOut">
               <a:rPr lang="en-US" smtClean="0"/>
-              <a:t>6/25/2026</a:t>
+              <a:t>6/26/2026</a:t>
             </a:fld>
             <a:endParaRPr lang="en-US"/>
           </a:p>
@@ -1613,7 +2088,7 @@
           <a:p>
             <a:fld id="{5BCAD085-E8A6-8845-BD4E-CB4CCA059FC4}" type="datetimeFigureOut">
               <a:rPr lang="en-US" smtClean="0"/>
-              <a:t>6/25/2026</a:t>
+              <a:t>6/26/2026</a:t>
             </a:fld>
             <a:endParaRPr lang="en-US"/>
           </a:p>
@@ -2032,7 +2507,7 @@
           <a:p>
             <a:fld id="{5BCAD085-E8A6-8845-BD4E-CB4CCA059FC4}" type="datetimeFigureOut">
               <a:rPr lang="en-US" smtClean="0"/>
-              <a:t>6/25/2026</a:t>
+              <a:t>6/26/2026</a:t>
             </a:fld>
             <a:endParaRPr lang="en-US"/>
           </a:p>
@@ -2149,7 +2624,7 @@
           <a:p>
             <a:fld id="{5BCAD085-E8A6-8845-BD4E-CB4CCA059FC4}" type="datetimeFigureOut">
               <a:rPr lang="en-US" smtClean="0"/>
-              <a:t>6/25/2026</a:t>
+              <a:t>6/26/2026</a:t>
             </a:fld>
             <a:endParaRPr lang="en-US"/>
           </a:p>
@@ -2244,7 +2719,7 @@
           <a:p>
             <a:fld id="{5BCAD085-E8A6-8845-BD4E-CB4CCA059FC4}" type="datetimeFigureOut">
               <a:rPr lang="en-US" smtClean="0"/>
-              <a:t>6/25/2026</a:t>
+              <a:t>6/26/2026</a:t>
             </a:fld>
             <a:endParaRPr lang="en-US"/>
           </a:p>
@@ -2519,7 +2994,7 @@
           <a:p>
             <a:fld id="{5BCAD085-E8A6-8845-BD4E-CB4CCA059FC4}" type="datetimeFigureOut">
               <a:rPr lang="en-US" smtClean="0"/>
-              <a:t>6/25/2026</a:t>
+              <a:t>6/26/2026</a:t>
             </a:fld>
             <a:endParaRPr lang="en-US"/>
           </a:p>
@@ -2771,7 +3246,7 @@
           <a:p>
             <a:fld id="{5BCAD085-E8A6-8845-BD4E-CB4CCA059FC4}" type="datetimeFigureOut">
               <a:rPr lang="en-US" smtClean="0"/>
-              <a:t>6/25/2026</a:t>
+              <a:t>6/26/2026</a:t>
             </a:fld>
             <a:endParaRPr lang="en-US"/>
           </a:p>
@@ -2982,7 +3457,7 @@
           <a:p>
             <a:fld id="{5BCAD085-E8A6-8845-BD4E-CB4CCA059FC4}" type="datetimeFigureOut">
               <a:rPr lang="en-US" smtClean="0"/>
-              <a:t>6/25/2026</a:t>
+              <a:t>6/26/2026</a:t>
             </a:fld>
             <a:endParaRPr lang="en-US"/>
           </a:p>
@@ -11076,7 +11551,24 @@
               </a:defRPr>
             </a:pPr>
             <a:r>
-              <a:t>Checklist — Ajouter une Nouvelle Série</a:t>
+              <a:rPr dirty="0"/>
+              <a:t>Checklist — </a:t>
+            </a:r>
+            <a:r>
+              <a:rPr dirty="0" err="1"/>
+              <a:t>Ajouter</a:t>
+            </a:r>
+            <a:r>
+              <a:rPr dirty="0"/>
+              <a:t> </a:t>
+            </a:r>
+            <a:r>
+              <a:rPr dirty="0" err="1"/>
+              <a:t>une</a:t>
+            </a:r>
+            <a:r>
+              <a:rPr dirty="0"/>
+              <a:t> Nouvelle Série</a:t>
             </a:r>
           </a:p>
         </p:txBody>
@@ -11103,491 +11595,133 @@
           </a:bodyPr>
           <a:lstStyle/>
           <a:p>
-            <a:pPr>
-              <a:spcBef>
-                <a:spcPts val="600"/>
-              </a:spcBef>
-              <a:defRPr sz="1400">
-                <a:solidFill>
-                  <a:srgbClr val="333333"/>
-                </a:solidFill>
-              </a:defRPr>
-            </a:pPr>
-            <a:r>
-              <a:rPr dirty="0"/>
-              <a:t> 1. </a:t>
-            </a:r>
-            <a:r>
-              <a:rPr dirty="0" err="1"/>
-              <a:t>Créer</a:t>
-            </a:r>
-            <a:r>
-              <a:rPr dirty="0"/>
-              <a:t> shared/config/config_&lt;</a:t>
-            </a:r>
-            <a:r>
-              <a:rPr dirty="0" err="1"/>
-              <a:t>serie</a:t>
-            </a:r>
-            <a:r>
-              <a:rPr dirty="0"/>
-              <a:t>&gt;.</a:t>
-            </a:r>
-            <a:r>
-              <a:rPr dirty="0" err="1"/>
-              <a:t>json</a:t>
-            </a:r>
-            <a:r>
-              <a:rPr dirty="0"/>
-              <a:t> (repos + </a:t>
-            </a:r>
-            <a:r>
-              <a:rPr dirty="0" err="1"/>
-              <a:t>clone_urls</a:t>
-            </a:r>
-            <a:r>
-              <a:rPr dirty="0"/>
-              <a:t>)</a:t>
-            </a:r>
-          </a:p>
-          <a:p>
-            <a:pPr>
-              <a:spcBef>
-                <a:spcPts val="600"/>
-              </a:spcBef>
-              <a:defRPr sz="1400">
-                <a:solidFill>
-                  <a:srgbClr val="333333"/>
-                </a:solidFill>
-              </a:defRPr>
-            </a:pPr>
-            <a:r>
-              <a:rPr dirty="0"/>
-              <a:t> 2. </a:t>
-            </a:r>
-            <a:r>
-              <a:rPr dirty="0" err="1"/>
-              <a:t>Ajouter</a:t>
-            </a:r>
-            <a:r>
-              <a:rPr dirty="0"/>
-              <a:t> mapping dans pipeline/delivery/delivery_paths.py</a:t>
-            </a:r>
-          </a:p>
-          <a:p>
-            <a:pPr>
-              <a:spcBef>
-                <a:spcPts val="600"/>
-              </a:spcBef>
-              <a:defRPr sz="1400">
-                <a:solidFill>
-                  <a:srgbClr val="333333"/>
-                </a:solidFill>
-              </a:defRPr>
-            </a:pPr>
-            <a:r>
-              <a:rPr dirty="0"/>
-              <a:t> 3. Lancer le pipeline </a:t>
-            </a:r>
-            <a:r>
-              <a:rPr dirty="0" err="1"/>
-              <a:t>complet</a:t>
-            </a:r>
-            <a:r>
-              <a:rPr dirty="0"/>
-              <a:t> :</a:t>
-            </a:r>
-          </a:p>
-          <a:p>
-            <a:pPr>
-              <a:spcBef>
-                <a:spcPts val="400"/>
-              </a:spcBef>
-              <a:defRPr sz="1200">
-                <a:solidFill>
-                  <a:srgbClr val="333333"/>
-                </a:solidFill>
-                <a:latin typeface="Consolas"/>
-              </a:defRPr>
-            </a:pPr>
-            <a:r>
-              <a:rPr dirty="0"/>
-              <a:t>$env:STM32CUBE_CONFIG = "shared/config/</a:t>
-            </a:r>
-            <a:r>
-              <a:rPr dirty="0" err="1"/>
-              <a:t>config_xx.json</a:t>
-            </a:r>
-            <a:r>
-              <a:rPr dirty="0"/>
-              <a:t>"</a:t>
-            </a:r>
-          </a:p>
-          <a:p>
-            <a:pPr>
-              <a:spcBef>
-                <a:spcPts val="400"/>
-              </a:spcBef>
-              <a:defRPr sz="1200">
-                <a:solidFill>
-                  <a:srgbClr val="333333"/>
-                </a:solidFill>
-                <a:latin typeface="Consolas"/>
-              </a:defRPr>
-            </a:pPr>
-            <a:r>
-              <a:rPr dirty="0"/>
-              <a:t>python -m </a:t>
-            </a:r>
-            <a:r>
-              <a:rPr dirty="0" err="1"/>
-              <a:t>pipeline.run_full_workflow</a:t>
-            </a:r>
-            <a:r>
-              <a:rPr dirty="0"/>
-              <a:t> --export-st-ready --continue-on-error</a:t>
-            </a:r>
-          </a:p>
-          <a:p>
-            <a:pPr>
-              <a:spcBef>
-                <a:spcPts val="600"/>
-              </a:spcBef>
-              <a:defRPr sz="1400">
-                <a:solidFill>
-                  <a:srgbClr val="333333"/>
-                </a:solidFill>
-              </a:defRPr>
-            </a:pPr>
-            <a:r>
-              <a:rPr dirty="0"/>
-              <a:t>  → </a:t>
-            </a:r>
-            <a:r>
-              <a:rPr dirty="0" err="1"/>
-              <a:t>Inclut</a:t>
-            </a:r>
-            <a:r>
-              <a:rPr dirty="0"/>
-              <a:t> </a:t>
-            </a:r>
-            <a:r>
-              <a:rPr dirty="0" err="1"/>
-              <a:t>automatiquement</a:t>
-            </a:r>
-            <a:r>
-              <a:rPr dirty="0"/>
-              <a:t>: delivery + export </a:t>
-            </a:r>
-            <a:r>
-              <a:rPr dirty="0" err="1"/>
-              <a:t>with_images</a:t>
-            </a:r>
-            <a:r>
-              <a:rPr dirty="0"/>
-              <a:t> + Alfred images</a:t>
-            </a:r>
-          </a:p>
-          <a:p>
-            <a:pPr>
-              <a:spcBef>
-                <a:spcPts val="600"/>
-              </a:spcBef>
-              <a:defRPr sz="1400">
-                <a:solidFill>
-                  <a:srgbClr val="333333"/>
-                </a:solidFill>
-              </a:defRPr>
-            </a:pPr>
-            <a:r>
-              <a:rPr dirty="0"/>
-              <a:t> 4. </a:t>
-            </a:r>
-            <a:r>
-              <a:rPr dirty="0" err="1"/>
-              <a:t>Vérifier</a:t>
-            </a:r>
-            <a:r>
-              <a:rPr dirty="0"/>
-              <a:t> </a:t>
-            </a:r>
-            <a:r>
-              <a:rPr dirty="0" err="1"/>
-              <a:t>by_series</a:t>
-            </a:r>
-            <a:r>
-              <a:rPr dirty="0"/>
-              <a:t>/&lt;</a:t>
-            </a:r>
-            <a:r>
-              <a:rPr dirty="0" err="1"/>
-              <a:t>serie</a:t>
-            </a:r>
-            <a:r>
-              <a:rPr dirty="0"/>
-              <a:t>&gt;/ : issues, files, </a:t>
-            </a:r>
-            <a:r>
-              <a:rPr dirty="0" err="1"/>
-              <a:t>diag</a:t>
-            </a:r>
-            <a:r>
-              <a:rPr dirty="0"/>
-              <a:t>, resolver, drivers/</a:t>
-            </a:r>
-          </a:p>
-          <a:p>
-            <a:pPr>
-              <a:spcBef>
-                <a:spcPts val="600"/>
-              </a:spcBef>
-              <a:defRPr sz="1400">
-                <a:solidFill>
-                  <a:srgbClr val="333333"/>
-                </a:solidFill>
-              </a:defRPr>
-            </a:pPr>
-            <a:r>
-              <a:rPr dirty="0"/>
-              <a:t> 5. Alfred PDF figures (</a:t>
-            </a:r>
-            <a:r>
-              <a:rPr dirty="0" err="1"/>
-              <a:t>si</a:t>
-            </a:r>
-            <a:r>
-              <a:rPr dirty="0"/>
-              <a:t> </a:t>
-            </a:r>
-            <a:r>
-              <a:rPr dirty="0" err="1"/>
-              <a:t>pdf_image_tasks</a:t>
-            </a:r>
-            <a:r>
-              <a:rPr dirty="0"/>
-              <a:t> non vide) :</a:t>
-            </a:r>
-          </a:p>
-          <a:p>
-            <a:pPr>
-              <a:spcBef>
-                <a:spcPts val="400"/>
-              </a:spcBef>
-              <a:defRPr sz="1200">
-                <a:solidFill>
-                  <a:srgbClr val="333333"/>
-                </a:solidFill>
-                <a:latin typeface="Consolas"/>
-              </a:defRPr>
-            </a:pPr>
-            <a:r>
-              <a:rPr dirty="0"/>
-              <a:t>python pipeline_Automation/alfred/enrich_pdf_figures_with_alfred.py --repo &lt;Repo&gt;</a:t>
-            </a:r>
-          </a:p>
-          <a:p>
-            <a:pPr>
-              <a:spcBef>
-                <a:spcPts val="600"/>
-              </a:spcBef>
-              <a:defRPr sz="1400">
-                <a:solidFill>
-                  <a:srgbClr val="333333"/>
-                </a:solidFill>
-              </a:defRPr>
-            </a:pPr>
-            <a:r>
-              <a:rPr dirty="0"/>
-              <a:t>  → </a:t>
-            </a:r>
-            <a:r>
-              <a:rPr dirty="0" err="1"/>
-              <a:t>Puis</a:t>
-            </a:r>
-            <a:r>
-              <a:rPr dirty="0"/>
-              <a:t> re-run: files_to_docs_v2 + </a:t>
-            </a:r>
-            <a:r>
-              <a:rPr dirty="0" err="1"/>
-              <a:t>export_st_ready_files</a:t>
-            </a:r>
-            <a:endParaRPr dirty="0"/>
-          </a:p>
-          <a:p>
-            <a:pPr>
-              <a:spcBef>
-                <a:spcPts val="600"/>
-              </a:spcBef>
-              <a:defRPr sz="1400">
-                <a:solidFill>
-                  <a:srgbClr val="333333"/>
-                </a:solidFill>
-              </a:defRPr>
-            </a:pPr>
-            <a:r>
-              <a:rPr dirty="0"/>
-              <a:t> 6. Upload repo principal (new </a:t>
-            </a:r>
-            <a:r>
-              <a:rPr dirty="0" err="1"/>
-              <a:t>datasource</a:t>
-            </a:r>
-            <a:r>
-              <a:rPr dirty="0"/>
-              <a:t> × 4 types)</a:t>
-            </a:r>
-          </a:p>
-          <a:p>
-            <a:pPr>
-              <a:spcBef>
-                <a:spcPts val="600"/>
-              </a:spcBef>
-              <a:defRPr sz="1400">
-                <a:solidFill>
-                  <a:srgbClr val="333333"/>
-                </a:solidFill>
-              </a:defRPr>
-            </a:pPr>
-            <a:r>
-              <a:rPr dirty="0"/>
-              <a:t> 7. Upload issues </a:t>
-            </a:r>
-            <a:r>
-              <a:rPr dirty="0" err="1"/>
-              <a:t>with_images</a:t>
-            </a:r>
-            <a:r>
-              <a:rPr dirty="0"/>
-              <a:t> </a:t>
-            </a:r>
-            <a:r>
-              <a:rPr dirty="0" err="1"/>
-              <a:t>enrichies</a:t>
-            </a:r>
-            <a:r>
-              <a:rPr dirty="0"/>
-              <a:t> Alfred</a:t>
-            </a:r>
-          </a:p>
-          <a:p>
-            <a:pPr>
-              <a:spcBef>
-                <a:spcPts val="600"/>
-              </a:spcBef>
-              <a:defRPr sz="1400">
-                <a:solidFill>
-                  <a:srgbClr val="333333"/>
-                </a:solidFill>
-              </a:defRPr>
-            </a:pPr>
-            <a:r>
-              <a:rPr dirty="0"/>
-              <a:t> 8. Upload files PDF-</a:t>
-            </a:r>
-            <a:r>
-              <a:rPr dirty="0" err="1"/>
-              <a:t>enrichies</a:t>
-            </a:r>
-            <a:r>
-              <a:rPr dirty="0"/>
-              <a:t> (</a:t>
-            </a:r>
-            <a:r>
-              <a:rPr dirty="0" err="1"/>
-              <a:t>suffixe</a:t>
-            </a:r>
-            <a:r>
-              <a:rPr dirty="0"/>
-              <a:t> _</a:t>
-            </a:r>
-            <a:r>
-              <a:rPr dirty="0" err="1"/>
-              <a:t>pdf_enriched</a:t>
-            </a:r>
-            <a:r>
-              <a:rPr dirty="0"/>
-              <a:t> </a:t>
-            </a:r>
-            <a:r>
-              <a:rPr dirty="0" err="1"/>
-              <a:t>si</a:t>
-            </a:r>
-            <a:r>
-              <a:rPr dirty="0"/>
-              <a:t> déjà </a:t>
-            </a:r>
-            <a:r>
-              <a:rPr dirty="0" err="1"/>
-              <a:t>uploadé</a:t>
-            </a:r>
-            <a:r>
-              <a:rPr dirty="0"/>
-              <a:t>)</a:t>
-            </a:r>
-          </a:p>
-          <a:p>
-            <a:pPr>
-              <a:spcBef>
-                <a:spcPts val="600"/>
-              </a:spcBef>
-              <a:defRPr sz="1400">
-                <a:solidFill>
-                  <a:srgbClr val="333333"/>
-                </a:solidFill>
-              </a:defRPr>
-            </a:pPr>
-            <a:r>
-              <a:rPr dirty="0"/>
-              <a:t> 9. </a:t>
-            </a:r>
-            <a:r>
-              <a:rPr dirty="0" err="1"/>
-              <a:t>Mettre</a:t>
-            </a:r>
-            <a:r>
-              <a:rPr dirty="0"/>
-              <a:t> à jour Upload_All_Drivers.ps1 + upload_alfred_issues_all_series.py</a:t>
-            </a:r>
-          </a:p>
-          <a:p>
-            <a:pPr>
-              <a:spcBef>
-                <a:spcPts val="600"/>
-              </a:spcBef>
-              <a:defRPr sz="1400">
-                <a:solidFill>
-                  <a:srgbClr val="333333"/>
-                </a:solidFill>
-              </a:defRPr>
-            </a:pPr>
-            <a:r>
-              <a:rPr dirty="0"/>
-              <a:t> 10. Lancer Upload_All_Drivers.ps1</a:t>
-            </a:r>
-          </a:p>
-          <a:p>
-            <a:pPr>
-              <a:spcBef>
-                <a:spcPts val="600"/>
-              </a:spcBef>
-              <a:defRPr sz="1400">
-                <a:solidFill>
-                  <a:srgbClr val="333333"/>
-                </a:solidFill>
-              </a:defRPr>
-            </a:pPr>
-            <a:r>
-              <a:rPr dirty="0"/>
-              <a:t> 11. </a:t>
-            </a:r>
-            <a:r>
-              <a:rPr dirty="0" err="1"/>
-              <a:t>Vérifier</a:t>
-            </a:r>
-            <a:r>
-              <a:rPr dirty="0"/>
-              <a:t>: Get_Persona_KBs.py</a:t>
+            <a:r>
+              <a:t>1. Créer config serie</a:t>
+            </a:r>
+          </a:p>
+          <a:p>
+            <a:r>
+              <a:t>Commande: New-Item "shared/config/config_&lt;serie&gt;.json" -ItemType File</a:t>
+            </a:r>
+          </a:p>
+          <a:p/>
+          <a:p>
+            <a:r>
+              <a:t>2. Ajouter mapping delivery_paths</a:t>
+            </a:r>
+          </a:p>
+          <a:p>
+            <a:r>
+              <a:t>Commande: code pipeline/delivery/delivery_paths.py</a:t>
+            </a:r>
+          </a:p>
+          <a:p/>
+          <a:p>
+            <a:r>
+              <a:t>3. Lancer pipeline complet</a:t>
+            </a:r>
+          </a:p>
+          <a:p>
+            <a:r>
+              <a:t>Commande: $env:STM32CUBE_CONFIG="shared/config/config_&lt;serie&gt;.json"</a:t>
+            </a:r>
+          </a:p>
+          <a:p>
+            <a:r>
+              <a:t>python -m pipeline.run_full_workflow --export-st-ready --continue-on-error</a:t>
+            </a:r>
+          </a:p>
+          <a:p/>
+          <a:p>
+            <a:r>
+              <a:t>4. Verifier outputs by_series</a:t>
+            </a:r>
+          </a:p>
+          <a:p>
+            <a:r>
+              <a:t>Commande: Get-ChildItem "datasets/07_delivery/st_ready/by_series/stm32cube&lt;serie&gt;" -Recurse</a:t>
+            </a:r>
+          </a:p>
+          <a:p/>
+          <a:p>
+            <a:r>
+              <a:t>5. Alfred PDF (si necessaire)</a:t>
+            </a:r>
+          </a:p>
+          <a:p>
+            <a:r>
+              <a:t>Commande: python pipeline_Automation/alfred/enrich_pdf_figures_with_alfred.py --repo STM32Cube&lt;SERIE&gt; --use-proxy</a:t>
+            </a:r>
+          </a:p>
+          <a:p/>
+          <a:p>
+            <a:r>
+              <a:t>6. Upload principal (workflow recommande)</a:t>
+            </a:r>
+          </a:p>
+          <a:p>
+            <a:r>
+              <a:t>Commande: .\pipeline_Automation\workflow\Run_Single_Series_Full_Pipeline_And_Upload.ps1 -Series &lt;SERIE&gt; -Mode Upload</a:t>
+            </a:r>
+          </a:p>
+          <a:p/>
+          <a:p>
+            <a:r>
+              <a:t>7. Upload issues with_images Alfred</a:t>
+            </a:r>
+          </a:p>
+          <a:p>
+            <a:r>
+              <a:t>Commande: python pipeline_Automation/upload/upload_alfred_issues_all_series.py</a:t>
+            </a:r>
+          </a:p>
+          <a:p/>
+          <a:p>
+            <a:r>
+              <a:t>8. Upload files PDF enrichis</a:t>
+            </a:r>
+          </a:p>
+          <a:p>
+            <a:r>
+              <a:t>Commande: python pipeline_Automation/patch_pdf_descriptions_in_delivery.py</a:t>
+            </a:r>
+          </a:p>
+          <a:p/>
+          <a:p>
+            <a:r>
+              <a:t>9. Mettre a jour scripts upload (si nouvelle serie)</a:t>
+            </a:r>
+          </a:p>
+          <a:p>
+            <a:r>
+              <a:t>Commandes: code pipeline_Automation/upload/Upload_All_Drivers.ps1</a:t>
+            </a:r>
+          </a:p>
+          <a:p>
+            <a:r>
+              <a:t>           code pipeline_Automation/upload/upload_alfred_issues_all_series.py</a:t>
+            </a:r>
+          </a:p>
+          <a:p/>
+          <a:p>
+            <a:r>
+              <a:t>10. Upload drivers</a:t>
+            </a:r>
+          </a:p>
+          <a:p>
+            <a:r>
+              <a:t>Commande: .\pipeline_Automation\upload\Upload_All_Drivers.ps1</a:t>
+            </a:r>
+          </a:p>
+          <a:p/>
+          <a:p>
+            <a:r>
+              <a:t>11. Verification KB</a:t>
+            </a:r>
+          </a:p>
+          <a:p>
+            <a:r>
+              <a:t>Commande: python pipeline_Automation/upload/Get_Persona_KBs.py</a:t>
             </a:r>
           </a:p>
         </p:txBody>
@@ -15135,7 +15269,7 @@
 </file>
 
 <file path=ppt/slides/slide32.xml><?xml version="1.0" encoding="utf-8"?>
-<p:sld xmlns:a="http://schemas.openxmlformats.org/drawingml/2006/main" xmlns:r="http://schemas.openxmlformats.org/officeDocument/2006/relationships" xmlns:p="http://schemas.openxmlformats.org/presentationml/2006/main">
+<p:sld xmlns:a="http://schemas.openxmlformats.org/drawingml/2006/main" xmlns:p="http://schemas.openxmlformats.org/presentationml/2006/main" xmlns:r="http://schemas.openxmlformats.org/officeDocument/2006/relationships">
   <p:cSld>
     <p:spTree>
       <p:nvGrpSpPr>
@@ -15143,120 +15277,367 @@
         <p:cNvGrpSpPr/>
         <p:nvPr/>
       </p:nvGrpSpPr>
-      <p:grpSpPr>
-        <a:xfrm>
-          <a:off x="0" y="0"/>
-          <a:ext cx="0" cy="0"/>
-          <a:chOff x="0" y="0"/>
-          <a:chExt cx="0" cy="0"/>
-        </a:xfrm>
-      </p:grpSpPr>
+      <p:grpSpPr/>
       <p:sp>
         <p:nvSpPr>
-          <p:cNvPr id="2" name="Title 1"/>
-          <p:cNvSpPr>
-            <a:spLocks noGrp="1"/>
-          </p:cNvSpPr>
-          <p:nvPr>
-            <p:ph type="title"/>
-          </p:nvPr>
+          <p:cNvPr id="2" name="Rectangle 1"/>
+          <p:cNvSpPr/>
+          <p:nvPr/>
         </p:nvSpPr>
-        <p:spPr/>
+        <p:spPr>
+          <a:xfrm>
+            <a:off x="0" y="0"/>
+            <a:ext cx="9144000" cy="822960"/>
+          </a:xfrm>
+          <a:prstGeom prst="rect">
+            <a:avLst/>
+          </a:prstGeom>
+          <a:solidFill>
+            <a:srgbClr val="034EA2"/>
+          </a:solidFill>
+          <a:ln>
+            <a:noFill/>
+          </a:ln>
+        </p:spPr>
+        <p:style>
+          <a:lnRef idx="1">
+            <a:schemeClr val="accent1"/>
+          </a:lnRef>
+          <a:fillRef idx="3">
+            <a:schemeClr val="accent1"/>
+          </a:fillRef>
+          <a:effectRef idx="2">
+            <a:schemeClr val="accent1"/>
+          </a:effectRef>
+          <a:fontRef idx="minor">
+            <a:schemeClr val="lt1"/>
+          </a:fontRef>
+        </p:style>
         <p:txBody>
-          <a:bodyPr>
-            <a:normAutofit fontScale="90000"/>
-          </a:bodyPr>
+          <a:bodyPr rtlCol="0" anchor="ctr"/>
           <a:lstStyle/>
           <a:p>
-            <a:r>
-              <a:t>Demo Alfred - Exemple 1 (Issue #335)</a:t>
+            <a:pPr algn="ctr">
+              <a:defRPr sz="2800" b="1">
+                <a:solidFill>
+                  <a:srgbClr val="FFFFFF"/>
+                </a:solidFill>
+              </a:defRPr>
+            </a:pPr>
+            <a:r>
+              <a:t>Differences entre les modes et les scripts</a:t>
             </a:r>
           </a:p>
         </p:txBody>
       </p:sp>
       <p:sp>
         <p:nvSpPr>
-          <p:cNvPr id="3" name="Content Placeholder 2"/>
-          <p:cNvSpPr>
-            <a:spLocks noGrp="1"/>
-          </p:cNvSpPr>
-          <p:nvPr>
-            <p:ph idx="1"/>
-          </p:nvPr>
+          <p:cNvPr id="3" name="TextBox 2"/>
+          <p:cNvSpPr txBox="1"/>
+          <p:nvPr/>
         </p:nvSpPr>
-        <p:spPr/>
+        <p:spPr>
+          <a:xfrm>
+            <a:off x="457200" y="1097280"/>
+            <a:ext cx="4206240" cy="5303520"/>
+          </a:xfrm>
+          <a:prstGeom prst="rect">
+            <a:avLst/>
+          </a:prstGeom>
+          <a:noFill/>
+        </p:spPr>
         <p:txBody>
-          <a:bodyPr>
-            <a:normAutofit/>
+          <a:bodyPr wrap="square">
+            <a:spAutoFit/>
           </a:bodyPr>
           <a:lstStyle/>
           <a:p>
-            <a:r>
-              <a:rPr sz="2000" dirty="0"/>
-              <a:t>Issue: warning -</a:t>
-            </a:r>
-            <a:r>
-              <a:rPr sz="2000" dirty="0" err="1"/>
-              <a:t>Wcast</a:t>
-            </a:r>
-            <a:r>
-              <a:rPr sz="2000" dirty="0"/>
-              <a:t>-align sur STM32CubeH7</a:t>
-            </a:r>
-          </a:p>
-          <a:p>
-            <a:r>
-              <a:rPr sz="2000" dirty="0"/>
-              <a:t>Integration dans </a:t>
-            </a:r>
-            <a:r>
-              <a:rPr sz="2000" dirty="0" err="1"/>
-              <a:t>st_ready_text</a:t>
-            </a:r>
-            <a:r>
-              <a:rPr sz="2000" dirty="0"/>
-              <a:t>: [IMAGE DESCRIPTION] Screenshot of an Eclipse/STM32CubeIDE project properties...</a:t>
-            </a:r>
-          </a:p>
-          <a:p>
-            <a:r>
-              <a:rPr sz="2000" dirty="0"/>
-              <a:t>Description Alfred (</a:t>
-            </a:r>
-            <a:r>
-              <a:rPr sz="2000" dirty="0" err="1"/>
-              <a:t>image_analyses</a:t>
-            </a:r>
-            <a:r>
-              <a:rPr sz="2000" dirty="0"/>
-              <a:t>): MCU/MPU GCC Linker &gt; Miscellaneous, flags linker </a:t>
-            </a:r>
-            <a:r>
-              <a:rPr sz="2000" dirty="0" err="1"/>
-              <a:t>detectes</a:t>
-            </a:r>
-            <a:endParaRPr sz="2000" dirty="0"/>
-          </a:p>
-          <a:p>
-            <a:r>
-              <a:rPr sz="2000" dirty="0"/>
-              <a:t>Impact retrieval: les captures IDE </a:t>
-            </a:r>
-            <a:r>
-              <a:rPr sz="2000" dirty="0" err="1"/>
-              <a:t>deviennent</a:t>
-            </a:r>
-            <a:r>
-              <a:rPr sz="2000" dirty="0"/>
-              <a:t> </a:t>
-            </a:r>
-            <a:r>
-              <a:rPr sz="2000" dirty="0" err="1"/>
-              <a:t>recherchables</a:t>
-            </a:r>
-            <a:r>
-              <a:rPr sz="2000" dirty="0"/>
-              <a:t> dans la KB</a:t>
+            <a:pPr>
+              <a:defRPr sz="1500" b="1"/>
+            </a:pPr>
+            <a:r>
+              <a:t>Modes de Run_Single_Series_Full_Pipeline_And_Upload.ps1</a:t>
+            </a:r>
+          </a:p>
+          <a:p>
+            <a:pPr>
+              <a:defRPr sz="1300" b="1"/>
+            </a:pPr>
+            <a:r>
+              <a:t>Mode Prepare :</a:t>
+            </a:r>
+          </a:p>
+          <a:p>
+            <a:pPr>
+              <a:defRPr sz="1300" b="0"/>
+            </a:pPr>
+            <a:r>
+              <a:t>- Définit STM32CUBE_CONFIG pour une seule série</a:t>
+            </a:r>
+          </a:p>
+          <a:p>
+            <a:pPr>
+              <a:defRPr sz="1300" b="0"/>
+            </a:pPr>
+            <a:r>
+              <a:t>- Exécute la synchronisation des repos + audit des sous-modules</a:t>
+            </a:r>
+          </a:p>
+          <a:p>
+            <a:pPr>
+              <a:defRPr sz="1300" b="0"/>
+            </a:pPr>
+            <a:r>
+              <a:t>- Lance pipeline.run_full_workflow --skip-chunking</a:t>
+            </a:r>
+          </a:p>
+          <a:p>
+            <a:pPr>
+              <a:defRPr sz="1300" b="0"/>
+            </a:pPr>
+            <a:r>
+              <a:t>- Exporte les JSON ST-ready (issues, files, resolver, diagnostic)</a:t>
+            </a:r>
+          </a:p>
+          <a:p>
+            <a:pPr>
+              <a:defRPr sz="1300" b="0"/>
+            </a:pPr>
+            <a:r>
+              <a:t>- Exécute l’enrichissement images Alfred + patch PDF + validation schéma + contrôles placeholders</a:t>
+            </a:r>
+          </a:p>
+          <a:p>
+            <a:pPr>
+              <a:defRPr sz="1300" b="0"/>
+            </a:pPr>
+          </a:p>
+          <a:p>
+            <a:pPr>
+              <a:defRPr sz="1300" b="1"/>
+            </a:pPr>
+            <a:r>
+              <a:t>Mode Upload :</a:t>
+            </a:r>
+          </a:p>
+          <a:p>
+            <a:pPr>
+              <a:defRPr sz="1300" b="0"/>
+            </a:pPr>
+            <a:r>
+              <a:t>- N’exécute PAS le pipeline ingestion/cleaning/enrichment</a:t>
+            </a:r>
+          </a:p>
+          <a:p>
+            <a:pPr>
+              <a:defRPr sz="1300" b="0"/>
+            </a:pPr>
+            <a:r>
+              <a:t>- Utilise les JSON de delivery existants sous datasets/07_delivery/st_ready/by_series/&lt;serie&gt;</a:t>
+            </a:r>
+          </a:p>
+          <a:p>
+            <a:pPr>
+              <a:defRPr sz="1300" b="0"/>
+            </a:pPr>
+            <a:r>
+              <a:t>- Crée ou alimente les datasources KB (issues/files/diagnostic/resolver)</a:t>
+            </a:r>
+          </a:p>
+          <a:p>
+            <a:pPr>
+              <a:defRPr sz="1300" b="0"/>
+            </a:pPr>
+            <a:r>
+              <a:t>- Uploade les datasets du repo parent et des drivers/sous-repos</a:t>
+            </a:r>
+          </a:p>
+          <a:p>
+            <a:pPr>
+              <a:defRPr sz="1300" b="0"/>
+            </a:pPr>
+          </a:p>
+          <a:p>
+            <a:pPr>
+              <a:defRPr sz="1300" b="1"/>
+            </a:pPr>
+            <a:r>
+              <a:t>Mode Full :</a:t>
+            </a:r>
+          </a:p>
+          <a:p>
+            <a:pPr>
+              <a:defRPr sz="1300" b="0"/>
+            </a:pPr>
+            <a:r>
+              <a:t>- Équivalent à Prepare + Upload en une seule commande</a:t>
+            </a:r>
+          </a:p>
+        </p:txBody>
+      </p:sp>
+      <p:sp>
+        <p:nvSpPr>
+          <p:cNvPr id="4" name="TextBox 3"/>
+          <p:cNvSpPr txBox="1"/>
+          <p:nvPr/>
+        </p:nvSpPr>
+        <p:spPr>
+          <a:xfrm>
+            <a:off x="4663440" y="1097280"/>
+            <a:ext cx="4023360" cy="5303520"/>
+          </a:xfrm>
+          <a:prstGeom prst="rect">
+            <a:avLst/>
+          </a:prstGeom>
+          <a:noFill/>
+        </p:spPr>
+        <p:txBody>
+          <a:bodyPr wrap="square">
+            <a:spAutoFit/>
+          </a:bodyPr>
+          <a:lstStyle/>
+          <a:p>
+            <a:pPr>
+              <a:defRPr sz="1500" b="1"/>
+            </a:pPr>
+            <a:r>
+              <a:t>run_full_workflow.py vs Run_Single_Series_Full_Pipeline_And_Upload.ps1</a:t>
+            </a:r>
+          </a:p>
+          <a:p>
+            <a:pPr>
+              <a:defRPr sz="1300" b="1"/>
+            </a:pPr>
+            <a:r>
+              <a:t>run_full_workflow.py :</a:t>
+            </a:r>
+          </a:p>
+          <a:p>
+            <a:pPr>
+              <a:defRPr sz="1300" b="0"/>
+            </a:pPr>
+            <a:r>
+              <a:t>- Orchestrateur Python du pipeline uniquement</a:t>
+            </a:r>
+          </a:p>
+          <a:p>
+            <a:pPr>
+              <a:defRPr sz="1300" b="0"/>
+            </a:pPr>
+            <a:r>
+              <a:t>- Exécute ingestion -&gt; cleaning -&gt; enrichment -&gt; similarité -&gt; chunking/stats/schéma</a:t>
+            </a:r>
+          </a:p>
+          <a:p>
+            <a:pPr>
+              <a:defRPr sz="1300" b="0"/>
+            </a:pPr>
+            <a:r>
+              <a:t>- Options : --skip-ingestion, --skip-chunking, --continue-on-error</a:t>
+            </a:r>
+          </a:p>
+          <a:p>
+            <a:pPr>
+              <a:defRPr sz="1300" b="0"/>
+            </a:pPr>
+            <a:r>
+              <a:t>- Helpers de delivery optionnels avec --export-st-ready</a:t>
+            </a:r>
+          </a:p>
+          <a:p>
+            <a:pPr>
+              <a:defRPr sz="1300" b="0"/>
+            </a:pPr>
+            <a:r>
+              <a:t>- Ne gère pas la création/l’upload des datasources KB</a:t>
+            </a:r>
+          </a:p>
+          <a:p>
+            <a:pPr>
+              <a:defRPr sz="1300" b="0"/>
+            </a:pPr>
+          </a:p>
+          <a:p>
+            <a:pPr>
+              <a:defRPr sz="1300" b="1"/>
+            </a:pPr>
+            <a:r>
+              <a:t>Run_Single_Series_Full_Pipeline_And_Upload.ps1 :</a:t>
+            </a:r>
+          </a:p>
+          <a:p>
+            <a:pPr>
+              <a:defRPr sz="1300" b="0"/>
+            </a:pPr>
+            <a:r>
+              <a:t>- Wrapper opérationnel de bout en bout pour une série STM32</a:t>
+            </a:r>
+          </a:p>
+          <a:p>
+            <a:pPr>
+              <a:defRPr sz="1300" b="0"/>
+            </a:pPr>
+            <a:r>
+              <a:t>- Sélectionne la config série + appelle run_full_workflow.py</a:t>
+            </a:r>
+          </a:p>
+          <a:p>
+            <a:pPr>
+              <a:defRPr sz="1300" b="0"/>
+            </a:pPr>
+            <a:r>
+              <a:t>- Ajoute les contrôles de gate delivery et placeholders</a:t>
+            </a:r>
+          </a:p>
+          <a:p>
+            <a:pPr>
+              <a:defRPr sz="1300" b="0"/>
+            </a:pPr>
+            <a:r>
+              <a:t>- Gère create/add des datasources et l’upload JSON vers la KB</a:t>
+            </a:r>
+          </a:p>
+          <a:p>
+            <a:pPr>
+              <a:defRPr sz="1300" b="0"/>
+            </a:pPr>
+            <a:r>
+              <a:t>- Supporte les modes opérationnels Prepare / Upload / Full</a:t>
+            </a:r>
+          </a:p>
+        </p:txBody>
+      </p:sp>
+      <p:sp>
+        <p:nvSpPr>
+          <p:cNvPr id="5" name="TextBox 4"/>
+          <p:cNvSpPr txBox="1"/>
+          <p:nvPr/>
+        </p:nvSpPr>
+        <p:spPr>
+          <a:xfrm>
+            <a:off x="548640" y="6400800"/>
+            <a:ext cx="8046720" cy="320040"/>
+          </a:xfrm>
+          <a:prstGeom prst="rect">
+            <a:avLst/>
+          </a:prstGeom>
+          <a:noFill/>
+        </p:spPr>
+        <p:txBody>
+          <a:bodyPr wrap="none">
+            <a:spAutoFit/>
+          </a:bodyPr>
+          <a:lstStyle/>
+          <a:p>
+            <a:pPr>
+              <a:defRPr sz="1100" i="1">
+                <a:solidFill>
+                  <a:srgbClr val="464646"/>
+                </a:solidFill>
+              </a:defRPr>
+            </a:pPr>
+            <a:r>
+              <a:t>Conseil : utiliser Prepare pour générer/valider les données, Upload pour pousser des JSON existants, Full pour l’automatisation complète.</a:t>
             </a:r>
           </a:p>
         </p:txBody>
@@ -15270,7 +15651,7 @@
 </file>
 
 <file path=ppt/slides/slide33.xml><?xml version="1.0" encoding="utf-8"?>
-<p:sld xmlns:a="http://schemas.openxmlformats.org/drawingml/2006/main" xmlns:r="http://schemas.openxmlformats.org/officeDocument/2006/relationships" xmlns:p="http://schemas.openxmlformats.org/presentationml/2006/main">
+<p:sld xmlns:a="http://schemas.openxmlformats.org/drawingml/2006/main" xmlns:p="http://schemas.openxmlformats.org/presentationml/2006/main" xmlns:r="http://schemas.openxmlformats.org/officeDocument/2006/relationships">
   <p:cSld>
     <p:spTree>
       <p:nvGrpSpPr>
@@ -15278,115 +15659,764 @@
         <p:cNvGrpSpPr/>
         <p:nvPr/>
       </p:nvGrpSpPr>
-      <p:grpSpPr>
-        <a:xfrm>
-          <a:off x="0" y="0"/>
-          <a:ext cx="0" cy="0"/>
-          <a:chOff x="0" y="0"/>
-          <a:chExt cx="0" cy="0"/>
-        </a:xfrm>
-      </p:grpSpPr>
+      <p:grpSpPr/>
       <p:sp>
         <p:nvSpPr>
-          <p:cNvPr id="2" name="Title 1"/>
-          <p:cNvSpPr>
-            <a:spLocks noGrp="1"/>
-          </p:cNvSpPr>
-          <p:nvPr>
-            <p:ph type="title"/>
-          </p:nvPr>
+          <p:cNvPr id="2" name="Rectangle 1"/>
+          <p:cNvSpPr/>
+          <p:nvPr/>
         </p:nvSpPr>
-        <p:spPr/>
+        <p:spPr>
+          <a:xfrm>
+            <a:off x="0" y="0"/>
+            <a:ext cx="9144000" cy="822960"/>
+          </a:xfrm>
+          <a:prstGeom prst="rect">
+            <a:avLst/>
+          </a:prstGeom>
+          <a:solidFill>
+            <a:srgbClr val="034EA2"/>
+          </a:solidFill>
+          <a:ln>
+            <a:noFill/>
+          </a:ln>
+        </p:spPr>
+        <p:style>
+          <a:lnRef idx="1">
+            <a:schemeClr val="accent1"/>
+          </a:lnRef>
+          <a:fillRef idx="3">
+            <a:schemeClr val="accent1"/>
+          </a:fillRef>
+          <a:effectRef idx="2">
+            <a:schemeClr val="accent1"/>
+          </a:effectRef>
+          <a:fontRef idx="minor">
+            <a:schemeClr val="lt1"/>
+          </a:fontRef>
+        </p:style>
         <p:txBody>
-          <a:bodyPr>
-            <a:normAutofit fontScale="90000"/>
-          </a:bodyPr>
+          <a:bodyPr rtlCol="0" anchor="ctr"/>
           <a:lstStyle/>
           <a:p>
-            <a:r>
-              <a:t>Demo Alfred - Exemple 2 (Issue #333)</a:t>
+            <a:pPr algn="l">
+              <a:defRPr sz="2700" b="1">
+                <a:solidFill>
+                  <a:srgbClr val="FFFFFF"/>
+                </a:solidFill>
+              </a:defRPr>
+            </a:pPr>
+            <a:r>
+              <a:t>Quand lancer Prepare / Upload / Full</a:t>
             </a:r>
           </a:p>
         </p:txBody>
       </p:sp>
       <p:sp>
         <p:nvSpPr>
-          <p:cNvPr id="3" name="Content Placeholder 2"/>
-          <p:cNvSpPr>
-            <a:spLocks noGrp="1"/>
-          </p:cNvSpPr>
-          <p:nvPr>
-            <p:ph idx="1"/>
-          </p:nvPr>
+          <p:cNvPr id="3" name="TextBox 2"/>
+          <p:cNvSpPr txBox="1"/>
+          <p:nvPr/>
         </p:nvSpPr>
-        <p:spPr/>
+        <p:spPr>
+          <a:xfrm>
+            <a:off x="457200" y="1051560"/>
+            <a:ext cx="2697480" cy="5440680"/>
+          </a:xfrm>
+          <a:prstGeom prst="rect">
+            <a:avLst/>
+          </a:prstGeom>
+          <a:noFill/>
+        </p:spPr>
         <p:txBody>
-          <a:bodyPr>
-            <a:normAutofit/>
+          <a:bodyPr wrap="square">
+            <a:spAutoFit/>
           </a:bodyPr>
           <a:lstStyle/>
           <a:p>
-            <a:r>
-              <a:rPr sz="2000" dirty="0"/>
-              <a:t>Issue: compile warnings avec flags GCC</a:t>
-            </a:r>
-          </a:p>
-          <a:p>
-            <a:r>
-              <a:rPr sz="2000" dirty="0"/>
-              <a:t>Integration dans </a:t>
-            </a:r>
-            <a:r>
-              <a:rPr sz="2000" dirty="0" err="1"/>
-              <a:t>st_ready_text</a:t>
-            </a:r>
-            <a:r>
-              <a:rPr sz="2000" dirty="0"/>
-              <a:t>: [IMAGE DESCRIPTION] Screenshot of the STM32CubeIDE 'About' dialog...</a:t>
-            </a:r>
-          </a:p>
-          <a:p>
-            <a:r>
-              <a:rPr sz="2000" dirty="0"/>
-              <a:t>Description Alfred (</a:t>
-            </a:r>
-            <a:r>
-              <a:rPr sz="2000" dirty="0" err="1"/>
-              <a:t>image_analyses</a:t>
-            </a:r>
-            <a:r>
-              <a:rPr sz="2000" dirty="0"/>
-              <a:t>): Version STM32CubeIDE 2.0.0 + Build 26820...</a:t>
-            </a:r>
-          </a:p>
-          <a:p>
-            <a:r>
-              <a:rPr sz="2000" dirty="0"/>
-              <a:t>Impact retrieval: le </a:t>
-            </a:r>
-            <a:r>
-              <a:rPr sz="2000" dirty="0" err="1"/>
-              <a:t>contexte</a:t>
-            </a:r>
-            <a:r>
-              <a:rPr sz="2000" dirty="0"/>
-              <a:t> de version </a:t>
-            </a:r>
-            <a:r>
-              <a:rPr sz="2000" dirty="0" err="1"/>
-              <a:t>outil</a:t>
-            </a:r>
-            <a:r>
-              <a:rPr sz="2000" dirty="0"/>
-              <a:t> est </a:t>
-            </a:r>
-            <a:r>
-              <a:rPr sz="2000" dirty="0" err="1"/>
-              <a:t>indexe</a:t>
-            </a:r>
-            <a:r>
-              <a:rPr sz="2000" dirty="0"/>
-              <a:t> et exploitable</a:t>
+            <a:pPr>
+              <a:defRPr sz="1500" b="1">
+                <a:solidFill>
+                  <a:srgbClr val="0A0A0A"/>
+                </a:solidFill>
+              </a:defRPr>
+            </a:pPr>
+            <a:r>
+              <a:t>Mode Prepare</a:t>
+            </a:r>
+          </a:p>
+          <a:p>
+            <a:pPr>
+              <a:defRPr sz="1250">
+                <a:solidFill>
+                  <a:srgbClr val="232323"/>
+                </a:solidFill>
+              </a:defRPr>
+            </a:pPr>
+            <a:r>
+              <a:t>À utiliser quand vous avez besoin d’un retraitement complet des données d’une série.</a:t>
+            </a:r>
+          </a:p>
+          <a:p>
+            <a:pPr>
+              <a:defRPr sz="1250">
+                <a:solidFill>
+                  <a:srgbClr val="232323"/>
+                </a:solidFill>
+              </a:defRPr>
+            </a:pPr>
+            <a:r>
+              <a:t>Exécute sync, audit, run_full_workflow, export delivery, enrichissement Alfred, puis gates.</a:t>
+            </a:r>
+          </a:p>
+          <a:p>
+            <a:pPr>
+              <a:defRPr sz="1250">
+                <a:solidFill>
+                  <a:srgbClr val="232323"/>
+                </a:solidFill>
+              </a:defRPr>
+            </a:pPr>
+            <a:r>
+              <a:t>À lancer avant Upload si les données source ont changé.</a:t>
+            </a:r>
+          </a:p>
+          <a:p>
+            <a:pPr>
+              <a:defRPr sz="1250">
+                <a:solidFill>
+                  <a:srgbClr val="232323"/>
+                </a:solidFill>
+              </a:defRPr>
+            </a:pPr>
+            <a:r>
+              <a:t>Cas typique : onboarding d’une nouvelle série ou repos mis à jour.</a:t>
+            </a:r>
+          </a:p>
+        </p:txBody>
+      </p:sp>
+      <p:sp>
+        <p:nvSpPr>
+          <p:cNvPr id="4" name="TextBox 3"/>
+          <p:cNvSpPr txBox="1"/>
+          <p:nvPr/>
+        </p:nvSpPr>
+        <p:spPr>
+          <a:xfrm>
+            <a:off x="3200400" y="1051560"/>
+            <a:ext cx="2697480" cy="5440680"/>
+          </a:xfrm>
+          <a:prstGeom prst="rect">
+            <a:avLst/>
+          </a:prstGeom>
+          <a:noFill/>
+        </p:spPr>
+        <p:txBody>
+          <a:bodyPr wrap="square">
+            <a:spAutoFit/>
+          </a:bodyPr>
+          <a:lstStyle/>
+          <a:p>
+            <a:pPr>
+              <a:defRPr sz="1500" b="1">
+                <a:solidFill>
+                  <a:srgbClr val="0A0A0A"/>
+                </a:solidFill>
+              </a:defRPr>
+            </a:pPr>
+            <a:r>
+              <a:t>Mode Upload</a:t>
+            </a:r>
+          </a:p>
+          <a:p>
+            <a:pPr>
+              <a:defRPr sz="1250">
+                <a:solidFill>
+                  <a:srgbClr val="232323"/>
+                </a:solidFill>
+              </a:defRPr>
+            </a:pPr>
+            <a:r>
+              <a:t>À utiliser quand les JSON ST-ready existent déjà et sont validés.</a:t>
+            </a:r>
+          </a:p>
+          <a:p>
+            <a:pPr>
+              <a:defRPr sz="1250">
+                <a:solidFill>
+                  <a:srgbClr val="232323"/>
+                </a:solidFill>
+              </a:defRPr>
+            </a:pPr>
+            <a:r>
+              <a:t>Ignore ingestion/cleaning/enrichment et pousse uniquement vers les datasources KB.</a:t>
+            </a:r>
+          </a:p>
+          <a:p>
+            <a:pPr>
+              <a:defRPr sz="1250">
+                <a:solidFill>
+                  <a:srgbClr val="232323"/>
+                </a:solidFill>
+              </a:defRPr>
+            </a:pPr>
+            <a:r>
+              <a:t>Idéal pour relancer après timeout API ou changement de datasource.</a:t>
+            </a:r>
+          </a:p>
+          <a:p>
+            <a:pPr>
+              <a:defRPr sz="1250">
+                <a:solidFill>
+                  <a:srgbClr val="232323"/>
+                </a:solidFill>
+              </a:defRPr>
+            </a:pPr>
+            <a:r>
+              <a:t>Le mode le plus rapide quand aucune régénération n’est nécessaire.</a:t>
+            </a:r>
+          </a:p>
+        </p:txBody>
+      </p:sp>
+      <p:sp>
+        <p:nvSpPr>
+          <p:cNvPr id="5" name="TextBox 4"/>
+          <p:cNvSpPr txBox="1"/>
+          <p:nvPr/>
+        </p:nvSpPr>
+        <p:spPr>
+          <a:xfrm>
+            <a:off x="5943600" y="1051560"/>
+            <a:ext cx="2743200" cy="5440680"/>
+          </a:xfrm>
+          <a:prstGeom prst="rect">
+            <a:avLst/>
+          </a:prstGeom>
+          <a:noFill/>
+        </p:spPr>
+        <p:txBody>
+          <a:bodyPr wrap="square">
+            <a:spAutoFit/>
+          </a:bodyPr>
+          <a:lstStyle/>
+          <a:p>
+            <a:pPr>
+              <a:defRPr sz="1500" b="1">
+                <a:solidFill>
+                  <a:srgbClr val="0A0A0A"/>
+                </a:solidFill>
+              </a:defRPr>
+            </a:pPr>
+            <a:r>
+              <a:t>Mode Full</a:t>
+            </a:r>
+          </a:p>
+          <a:p>
+            <a:pPr>
+              <a:defRPr sz="1250">
+                <a:solidFill>
+                  <a:srgbClr val="232323"/>
+                </a:solidFill>
+              </a:defRPr>
+            </a:pPr>
+            <a:r>
+              <a:t>À utiliser pour une automatisation complète de bout en bout en une commande.</a:t>
+            </a:r>
+          </a:p>
+          <a:p>
+            <a:pPr>
+              <a:defRPr sz="1250">
+                <a:solidFill>
+                  <a:srgbClr val="232323"/>
+                </a:solidFill>
+              </a:defRPr>
+            </a:pPr>
+            <a:r>
+              <a:t>Équivalent à Prepare puis Upload.</a:t>
+            </a:r>
+          </a:p>
+          <a:p>
+            <a:pPr>
+              <a:defRPr sz="1250">
+                <a:solidFill>
+                  <a:srgbClr val="232323"/>
+                </a:solidFill>
+              </a:defRPr>
+            </a:pPr>
+            <a:r>
+              <a:t>Adapté aux exécutions batch quand l’environnement est stable.</a:t>
+            </a:r>
+          </a:p>
+          <a:p>
+            <a:pPr>
+              <a:defRPr sz="1250">
+                <a:solidFill>
+                  <a:srgbClr val="232323"/>
+                </a:solidFill>
+              </a:defRPr>
+            </a:pPr>
+            <a:r>
+              <a:t>À éviter si vous avez seulement besoin de relancer un upload (utiliser Upload).</a:t>
+            </a:r>
+          </a:p>
+        </p:txBody>
+      </p:sp>
+      <p:sp>
+        <p:nvSpPr>
+          <p:cNvPr id="6" name="TextBox 5"/>
+          <p:cNvSpPr txBox="1"/>
+          <p:nvPr/>
+        </p:nvSpPr>
+        <p:spPr>
+          <a:xfrm>
+            <a:off x="548640" y="6355080"/>
+            <a:ext cx="8138160" cy="320040"/>
+          </a:xfrm>
+          <a:prstGeom prst="rect">
+            <a:avLst/>
+          </a:prstGeom>
+          <a:noFill/>
+        </p:spPr>
+        <p:txBody>
+          <a:bodyPr wrap="none">
+            <a:spAutoFit/>
+          </a:bodyPr>
+          <a:lstStyle/>
+          <a:p>
+            <a:pPr>
+              <a:defRPr sz="1100" i="1">
+                <a:solidFill>
+                  <a:srgbClr val="464646"/>
+                </a:solidFill>
+              </a:defRPr>
+            </a:pPr>
+            <a:r>
+              <a:t>Règle simple : données changées -&gt; Prepare ; données prêtes -&gt; Upload ; premier run complet -&gt; Full.</a:t>
+            </a:r>
+          </a:p>
+        </p:txBody>
+      </p:sp>
+    </p:spTree>
+  </p:cSld>
+  <p:clrMapOvr>
+    <a:masterClrMapping/>
+  </p:clrMapOvr>
+</p:sld>
+</file>
+
+<file path=ppt/slides/slide34.xml><?xml version="1.0" encoding="utf-8"?>
+<p:sld xmlns:a="http://schemas.openxmlformats.org/drawingml/2006/main" xmlns:p="http://schemas.openxmlformats.org/presentationml/2006/main" xmlns:r="http://schemas.openxmlformats.org/officeDocument/2006/relationships">
+  <p:cSld>
+    <p:spTree>
+      <p:nvGrpSpPr>
+        <p:cNvPr id="1" name=""/>
+        <p:cNvGrpSpPr/>
+        <p:nvPr/>
+      </p:nvGrpSpPr>
+      <p:grpSpPr/>
+      <p:sp>
+        <p:nvSpPr>
+          <p:cNvPr id="2" name="Rectangle 1"/>
+          <p:cNvSpPr/>
+          <p:nvPr/>
+        </p:nvSpPr>
+        <p:spPr>
+          <a:xfrm>
+            <a:off x="0" y="0"/>
+            <a:ext cx="9144000" cy="822960"/>
+          </a:xfrm>
+          <a:prstGeom prst="rect">
+            <a:avLst/>
+          </a:prstGeom>
+          <a:solidFill>
+            <a:srgbClr val="034EA2"/>
+          </a:solidFill>
+          <a:ln>
+            <a:noFill/>
+          </a:ln>
+        </p:spPr>
+        <p:style>
+          <a:lnRef idx="1">
+            <a:schemeClr val="accent1"/>
+          </a:lnRef>
+          <a:fillRef idx="3">
+            <a:schemeClr val="accent1"/>
+          </a:fillRef>
+          <a:effectRef idx="2">
+            <a:schemeClr val="accent1"/>
+          </a:effectRef>
+          <a:fontRef idx="minor">
+            <a:schemeClr val="lt1"/>
+          </a:fontRef>
+        </p:style>
+        <p:txBody>
+          <a:bodyPr rtlCol="0" anchor="ctr"/>
+          <a:lstStyle/>
+          <a:p>
+            <a:pPr algn="l">
+              <a:defRPr sz="2700" b="1">
+                <a:solidFill>
+                  <a:srgbClr val="FFFFFF"/>
+                </a:solidFill>
+              </a:defRPr>
+            </a:pPr>
+            <a:r>
+              <a:t>Créer config_&lt;serie&gt;.json : quoi remplir et d’où viennent les informations</a:t>
+            </a:r>
+          </a:p>
+        </p:txBody>
+      </p:sp>
+      <p:sp>
+        <p:nvSpPr>
+          <p:cNvPr id="3" name="TextBox 2"/>
+          <p:cNvSpPr txBox="1"/>
+          <p:nvPr/>
+        </p:nvSpPr>
+        <p:spPr>
+          <a:xfrm>
+            <a:off x="457200" y="1051560"/>
+            <a:ext cx="4160520" cy="2514600"/>
+          </a:xfrm>
+          <a:prstGeom prst="rect">
+            <a:avLst/>
+          </a:prstGeom>
+          <a:noFill/>
+        </p:spPr>
+        <p:txBody>
+          <a:bodyPr wrap="square">
+            <a:spAutoFit/>
+          </a:bodyPr>
+          <a:lstStyle/>
+          <a:p>
+            <a:pPr>
+              <a:defRPr sz="1500" b="1">
+                <a:solidFill>
+                  <a:srgbClr val="0A0A0A"/>
+                </a:solidFill>
+              </a:defRPr>
+            </a:pPr>
+            <a:r>
+              <a:t>Étape 1 : créer le fichier</a:t>
+            </a:r>
+          </a:p>
+          <a:p>
+            <a:pPr>
+              <a:defRPr sz="1250">
+                <a:solidFill>
+                  <a:srgbClr val="232323"/>
+                </a:solidFill>
+              </a:defRPr>
+            </a:pPr>
+            <a:r>
+              <a:t>Cette commande crée seulement un fichier vide :</a:t>
+            </a:r>
+          </a:p>
+          <a:p>
+            <a:pPr>
+              <a:defRPr sz="1250">
+                <a:solidFill>
+                  <a:srgbClr val="232323"/>
+                </a:solidFill>
+              </a:defRPr>
+            </a:pPr>
+            <a:r>
+              <a:t>New-Item "shared/config/config_&lt;serie&gt;.json" -ItemType File</a:t>
+            </a:r>
+          </a:p>
+          <a:p>
+            <a:pPr>
+              <a:defRPr sz="1250">
+                <a:solidFill>
+                  <a:srgbClr val="232323"/>
+                </a:solidFill>
+              </a:defRPr>
+            </a:pPr>
+            <a:r>
+              <a:t>Ensuite, coller un modèle JSON (owner, repos, refs, rate limits).</a:t>
+            </a:r>
+          </a:p>
+        </p:txBody>
+      </p:sp>
+      <p:sp>
+        <p:nvSpPr>
+          <p:cNvPr id="4" name="TextBox 3"/>
+          <p:cNvSpPr txBox="1"/>
+          <p:nvPr/>
+        </p:nvSpPr>
+        <p:spPr>
+          <a:xfrm>
+            <a:off x="4663440" y="1051560"/>
+            <a:ext cx="3977639" cy="2514600"/>
+          </a:xfrm>
+          <a:prstGeom prst="rect">
+            <a:avLst/>
+          </a:prstGeom>
+          <a:noFill/>
+        </p:spPr>
+        <p:txBody>
+          <a:bodyPr wrap="square">
+            <a:spAutoFit/>
+          </a:bodyPr>
+          <a:lstStyle/>
+          <a:p>
+            <a:pPr>
+              <a:defRPr sz="1500" b="1">
+                <a:solidFill>
+                  <a:srgbClr val="0A0A0A"/>
+                </a:solidFill>
+              </a:defRPr>
+            </a:pPr>
+            <a:r>
+              <a:t>Étape 2 : remplir les champs requis</a:t>
+            </a:r>
+          </a:p>
+          <a:p>
+            <a:pPr>
+              <a:defRPr sz="1250">
+                <a:solidFill>
+                  <a:srgbClr val="232323"/>
+                </a:solidFill>
+              </a:defRPr>
+            </a:pPr>
+            <a:r>
+              <a:t>owner : en général STMicroelectronics</a:t>
+            </a:r>
+          </a:p>
+          <a:p>
+            <a:pPr>
+              <a:defRPr sz="1250">
+                <a:solidFill>
+                  <a:srgbClr val="232323"/>
+                </a:solidFill>
+              </a:defRPr>
+            </a:pPr>
+            <a:r>
+              <a:t>repos : repo parent + repos driver/CMSIS/BSP</a:t>
+            </a:r>
+          </a:p>
+          <a:p>
+            <a:pPr>
+              <a:defRPr sz="1250">
+                <a:solidFill>
+                  <a:srgbClr val="232323"/>
+                </a:solidFill>
+              </a:defRPr>
+            </a:pPr>
+            <a:r>
+              <a:t>repos_dir : racine locale des clones (par défaut GitHub_repos)</a:t>
+            </a:r>
+          </a:p>
+          <a:p>
+            <a:pPr>
+              <a:defRPr sz="1250">
+                <a:solidFill>
+                  <a:srgbClr val="232323"/>
+                </a:solidFill>
+              </a:defRPr>
+            </a:pPr>
+            <a:r>
+              <a:t>auto_clone_missing_repos : true pour clone/sync automatique</a:t>
+            </a:r>
+          </a:p>
+        </p:txBody>
+      </p:sp>
+      <p:sp>
+        <p:nvSpPr>
+          <p:cNvPr id="5" name="TextBox 4"/>
+          <p:cNvSpPr txBox="1"/>
+          <p:nvPr/>
+        </p:nvSpPr>
+        <p:spPr>
+          <a:xfrm>
+            <a:off x="457200" y="3611880"/>
+            <a:ext cx="4160520" cy="2743200"/>
+          </a:xfrm>
+          <a:prstGeom prst="rect">
+            <a:avLst/>
+          </a:prstGeom>
+          <a:noFill/>
+        </p:spPr>
+        <p:txBody>
+          <a:bodyPr wrap="square">
+            <a:spAutoFit/>
+          </a:bodyPr>
+          <a:lstStyle/>
+          <a:p>
+            <a:pPr>
+              <a:defRPr sz="1500" b="1">
+                <a:solidFill>
+                  <a:srgbClr val="0A0A0A"/>
+                </a:solidFill>
+              </a:defRPr>
+            </a:pPr>
+            <a:r>
+              <a:t>Source des informations</a:t>
+            </a:r>
+          </a:p>
+          <a:p>
+            <a:pPr>
+              <a:defRPr sz="1250">
+                <a:solidFill>
+                  <a:srgbClr val="232323"/>
+                </a:solidFill>
+              </a:defRPr>
+            </a:pPr>
+            <a:r>
+              <a:t>Nom du repo principal depuis la map des séries du workflow (STM32Cube&lt;Serie&gt;).</a:t>
+            </a:r>
+          </a:p>
+          <a:p>
+            <a:pPr>
+              <a:defRPr sz="1250">
+                <a:solidFill>
+                  <a:srgbClr val="232323"/>
+                </a:solidFill>
+              </a:defRPr>
+            </a:pPr>
+            <a:r>
+              <a:t>Sous-repos récupérés depuis le .gitmodules du repo parent.</a:t>
+            </a:r>
+          </a:p>
+          <a:p>
+            <a:pPr>
+              <a:defRPr sz="1250">
+                <a:solidFill>
+                  <a:srgbClr val="232323"/>
+                </a:solidFill>
+              </a:defRPr>
+            </a:pPr>
+            <a:r>
+              <a:t>Commande : python -m pipeline.evaluation.audit_config_submodules --fix</a:t>
+            </a:r>
+          </a:p>
+          <a:p>
+            <a:pPr>
+              <a:defRPr sz="1250">
+                <a:solidFill>
+                  <a:srgbClr val="232323"/>
+                </a:solidFill>
+              </a:defRPr>
+            </a:pPr>
+            <a:r>
+              <a:t>Cette commande auto-remplit les repos manquants + repo_clone_urls + linked_repo_refs.</a:t>
+            </a:r>
+          </a:p>
+        </p:txBody>
+      </p:sp>
+      <p:sp>
+        <p:nvSpPr>
+          <p:cNvPr id="6" name="TextBox 5"/>
+          <p:cNvSpPr txBox="1"/>
+          <p:nvPr/>
+        </p:nvSpPr>
+        <p:spPr>
+          <a:xfrm>
+            <a:off x="4663440" y="3611880"/>
+            <a:ext cx="3977639" cy="2743200"/>
+          </a:xfrm>
+          <a:prstGeom prst="rect">
+            <a:avLst/>
+          </a:prstGeom>
+          <a:noFill/>
+        </p:spPr>
+        <p:txBody>
+          <a:bodyPr wrap="square">
+            <a:spAutoFit/>
+          </a:bodyPr>
+          <a:lstStyle/>
+          <a:p>
+            <a:pPr>
+              <a:defRPr sz="1500" b="1">
+                <a:solidFill>
+                  <a:srgbClr val="0A0A0A"/>
+                </a:solidFill>
+              </a:defRPr>
+            </a:pPr>
+            <a:r>
+              <a:t>Comment le pipeline utilise la config</a:t>
+            </a:r>
+          </a:p>
+          <a:p>
+            <a:pPr>
+              <a:defRPr sz="1250">
+                <a:solidFill>
+                  <a:srgbClr val="232323"/>
+                </a:solidFill>
+              </a:defRPr>
+            </a:pPr>
+            <a:r>
+              <a:t>La config active est sélectionnée via STM32CUBE_CONFIG (shared/utils/paths.py).</a:t>
+            </a:r>
+          </a:p>
+          <a:p>
+            <a:pPr>
+              <a:defRPr sz="1250">
+                <a:solidFill>
+                  <a:srgbClr val="232323"/>
+                </a:solidFill>
+              </a:defRPr>
+            </a:pPr>
+            <a:r>
+              <a:t>L’ingestion utilise owner/repos et les paramètres de clone.</a:t>
+            </a:r>
+          </a:p>
+          <a:p>
+            <a:pPr>
+              <a:defRPr sz="1250">
+                <a:solidFill>
+                  <a:srgbClr val="232323"/>
+                </a:solidFill>
+              </a:defRPr>
+            </a:pPr>
+            <a:r>
+              <a:t>repo_clone_urls surcharge l’URL de clone quand le nom de repo diffère.</a:t>
+            </a:r>
+          </a:p>
+          <a:p>
+            <a:pPr>
+              <a:defRPr sz="1250">
+                <a:solidFill>
+                  <a:srgbClr val="232323"/>
+                </a:solidFill>
+              </a:defRPr>
+            </a:pPr>
+            <a:r>
+              <a:t>linked_repo_refs fixe les sous-repos sur des commits précis (reproductibilité).</a:t>
+            </a:r>
+          </a:p>
+        </p:txBody>
+      </p:sp>
+      <p:sp>
+        <p:nvSpPr>
+          <p:cNvPr id="7" name="TextBox 6"/>
+          <p:cNvSpPr txBox="1"/>
+          <p:nvPr/>
+        </p:nvSpPr>
+        <p:spPr>
+          <a:xfrm>
+            <a:off x="502920" y="6373368"/>
+            <a:ext cx="8183879" cy="274320"/>
+          </a:xfrm>
+          <a:prstGeom prst="rect">
+            <a:avLst/>
+          </a:prstGeom>
+          <a:noFill/>
+        </p:spPr>
+        <p:txBody>
+          <a:bodyPr wrap="none">
+            <a:spAutoFit/>
+          </a:bodyPr>
+          <a:lstStyle/>
+          <a:p>
+            <a:pPr>
+              <a:defRPr sz="1100" i="1">
+                <a:solidFill>
+                  <a:srgbClr val="464646"/>
+                </a:solidFill>
+              </a:defRPr>
+            </a:pPr>
+            <a:r>
+              <a:t>Flux recommandé : créer la config -&gt; lancer audit submodules --fix -&gt; vérifier les refs -&gt; lancer le mode Prepare.</a:t>
             </a:r>
           </a:p>
         </p:txBody>
@@ -18359,6 +19389,321 @@
 </a:theme>
 </file>
 
+<file path=ppt/theme/theme2.xml><?xml version="1.0" encoding="utf-8"?>
+<a:theme xmlns:a="http://schemas.openxmlformats.org/drawingml/2006/main" name="Office Theme">
+  <a:themeElements>
+    <a:clrScheme name="Office">
+      <a:dk1>
+        <a:sysClr val="windowText" lastClr="000000"/>
+      </a:dk1>
+      <a:lt1>
+        <a:sysClr val="window" lastClr="FFFFFF"/>
+      </a:lt1>
+      <a:dk2>
+        <a:srgbClr val="0E2841"/>
+      </a:dk2>
+      <a:lt2>
+        <a:srgbClr val="E8E8E8"/>
+      </a:lt2>
+      <a:accent1>
+        <a:srgbClr val="156082"/>
+      </a:accent1>
+      <a:accent2>
+        <a:srgbClr val="E97132"/>
+      </a:accent2>
+      <a:accent3>
+        <a:srgbClr val="196B24"/>
+      </a:accent3>
+      <a:accent4>
+        <a:srgbClr val="0F9ED5"/>
+      </a:accent4>
+      <a:accent5>
+        <a:srgbClr val="A02B93"/>
+      </a:accent5>
+      <a:accent6>
+        <a:srgbClr val="4EA72E"/>
+      </a:accent6>
+      <a:hlink>
+        <a:srgbClr val="467886"/>
+      </a:hlink>
+      <a:folHlink>
+        <a:srgbClr val="96607D"/>
+      </a:folHlink>
+    </a:clrScheme>
+    <a:fontScheme name="Office">
+      <a:majorFont>
+        <a:latin typeface="Aptos Display" panose="02110004020202020204"/>
+        <a:ea typeface=""/>
+        <a:cs typeface=""/>
+        <a:font script="Jpan" typeface="游ゴシック Light"/>
+        <a:font script="Hang" typeface="맑은 고딕"/>
+        <a:font script="Hans" typeface="等线 Light"/>
+        <a:font script="Hant" typeface="新細明體"/>
+        <a:font script="Arab" typeface="Times New Roman"/>
+        <a:font script="Hebr" typeface="Times New Roman"/>
+        <a:font script="Thai" typeface="Angsana New"/>
+        <a:font script="Ethi" typeface="Nyala"/>
+        <a:font script="Beng" typeface="Vrinda"/>
+        <a:font script="Gujr" typeface="Shruti"/>
+        <a:font script="Khmr" typeface="MoolBoran"/>
+        <a:font script="Knda" typeface="Tunga"/>
+        <a:font script="Guru" typeface="Raavi"/>
+        <a:font script="Cans" typeface="Euphemia"/>
+        <a:font script="Cher" typeface="Plantagenet Cherokee"/>
+        <a:font script="Yiii" typeface="Microsoft Yi Baiti"/>
+        <a:font script="Tibt" typeface="Microsoft Himalaya"/>
+        <a:font script="Thaa" typeface="MV Boli"/>
+        <a:font script="Deva" typeface="Mangal"/>
+        <a:font script="Telu" typeface="Gautami"/>
+        <a:font script="Taml" typeface="Latha"/>
+        <a:font script="Syrc" typeface="Estrangelo Edessa"/>
+        <a:font script="Orya" typeface="Kalinga"/>
+        <a:font script="Mlym" typeface="Kartika"/>
+        <a:font script="Laoo" typeface="DokChampa"/>
+        <a:font script="Sinh" typeface="Iskoola Pota"/>
+        <a:font script="Mong" typeface="Mongolian Baiti"/>
+        <a:font script="Viet" typeface="Times New Roman"/>
+        <a:font script="Uigh" typeface="Microsoft Uighur"/>
+        <a:font script="Geor" typeface="Sylfaen"/>
+        <a:font script="Armn" typeface="Arial"/>
+        <a:font script="Bugi" typeface="Leelawadee UI"/>
+        <a:font script="Bopo" typeface="Microsoft JhengHei"/>
+        <a:font script="Java" typeface="Javanese Text"/>
+        <a:font script="Lisu" typeface="Segoe UI"/>
+        <a:font script="Mymr" typeface="Myanmar Text"/>
+        <a:font script="Nkoo" typeface="Ebrima"/>
+        <a:font script="Olck" typeface="Nirmala UI"/>
+        <a:font script="Osma" typeface="Ebrima"/>
+        <a:font script="Phag" typeface="Phagspa"/>
+        <a:font script="Syrn" typeface="Estrangelo Edessa"/>
+        <a:font script="Syrj" typeface="Estrangelo Edessa"/>
+        <a:font script="Syre" typeface="Estrangelo Edessa"/>
+        <a:font script="Sora" typeface="Nirmala UI"/>
+        <a:font script="Tale" typeface="Microsoft Tai Le"/>
+        <a:font script="Talu" typeface="Microsoft New Tai Lue"/>
+        <a:font script="Tfng" typeface="Ebrima"/>
+      </a:majorFont>
+      <a:minorFont>
+        <a:latin typeface="Aptos" panose="02110004020202020204"/>
+        <a:ea typeface=""/>
+        <a:cs typeface=""/>
+        <a:font script="Jpan" typeface="游ゴシック"/>
+        <a:font script="Hang" typeface="맑은 고딕"/>
+        <a:font script="Hans" typeface="等线"/>
+        <a:font script="Hant" typeface="新細明體"/>
+        <a:font script="Arab" typeface="Arial"/>
+        <a:font script="Hebr" typeface="Arial"/>
+        <a:font script="Thai" typeface="Cordia New"/>
+        <a:font script="Ethi" typeface="Nyala"/>
+        <a:font script="Beng" typeface="Vrinda"/>
+        <a:font script="Gujr" typeface="Shruti"/>
+        <a:font script="Khmr" typeface="DaunPenh"/>
+        <a:font script="Knda" typeface="Tunga"/>
+        <a:font script="Guru" typeface="Raavi"/>
+        <a:font script="Cans" typeface="Euphemia"/>
+        <a:font script="Cher" typeface="Plantagenet Cherokee"/>
+        <a:font script="Yiii" typeface="Microsoft Yi Baiti"/>
+        <a:font script="Tibt" typeface="Microsoft Himalaya"/>
+        <a:font script="Thaa" typeface="MV Boli"/>
+        <a:font script="Deva" typeface="Mangal"/>
+        <a:font script="Telu" typeface="Gautami"/>
+        <a:font script="Taml" typeface="Latha"/>
+        <a:font script="Syrc" typeface="Estrangelo Edessa"/>
+        <a:font script="Orya" typeface="Kalinga"/>
+        <a:font script="Mlym" typeface="Kartika"/>
+        <a:font script="Laoo" typeface="DokChampa"/>
+        <a:font script="Sinh" typeface="Iskoola Pota"/>
+        <a:font script="Mong" typeface="Mongolian Baiti"/>
+        <a:font script="Viet" typeface="Arial"/>
+        <a:font script="Uigh" typeface="Microsoft Uighur"/>
+        <a:font script="Geor" typeface="Sylfaen"/>
+        <a:font script="Armn" typeface="Arial"/>
+        <a:font script="Bugi" typeface="Leelawadee UI"/>
+        <a:font script="Bopo" typeface="Microsoft JhengHei"/>
+        <a:font script="Java" typeface="Javanese Text"/>
+        <a:font script="Lisu" typeface="Segoe UI"/>
+        <a:font script="Mymr" typeface="Myanmar Text"/>
+        <a:font script="Nkoo" typeface="Ebrima"/>
+        <a:font script="Olck" typeface="Nirmala UI"/>
+        <a:font script="Osma" typeface="Ebrima"/>
+        <a:font script="Phag" typeface="Phagspa"/>
+        <a:font script="Syrn" typeface="Estrangelo Edessa"/>
+        <a:font script="Syrj" typeface="Estrangelo Edessa"/>
+        <a:font script="Syre" typeface="Estrangelo Edessa"/>
+        <a:font script="Sora" typeface="Nirmala UI"/>
+        <a:font script="Tale" typeface="Microsoft Tai Le"/>
+        <a:font script="Talu" typeface="Microsoft New Tai Lue"/>
+        <a:font script="Tfng" typeface="Ebrima"/>
+      </a:minorFont>
+    </a:fontScheme>
+    <a:fmtScheme name="Office">
+      <a:fillStyleLst>
+        <a:solidFill>
+          <a:schemeClr val="phClr"/>
+        </a:solidFill>
+        <a:gradFill rotWithShape="1">
+          <a:gsLst>
+            <a:gs pos="0">
+              <a:schemeClr val="phClr">
+                <a:lumMod val="110000"/>
+                <a:satMod val="105000"/>
+                <a:tint val="67000"/>
+              </a:schemeClr>
+            </a:gs>
+            <a:gs pos="50000">
+              <a:schemeClr val="phClr">
+                <a:lumMod val="105000"/>
+                <a:satMod val="103000"/>
+                <a:tint val="73000"/>
+              </a:schemeClr>
+            </a:gs>
+            <a:gs pos="100000">
+              <a:schemeClr val="phClr">
+                <a:lumMod val="105000"/>
+                <a:satMod val="109000"/>
+                <a:tint val="81000"/>
+              </a:schemeClr>
+            </a:gs>
+          </a:gsLst>
+          <a:lin ang="5400000" scaled="0"/>
+        </a:gradFill>
+        <a:gradFill rotWithShape="1">
+          <a:gsLst>
+            <a:gs pos="0">
+              <a:schemeClr val="phClr">
+                <a:satMod val="103000"/>
+                <a:lumMod val="102000"/>
+                <a:tint val="94000"/>
+              </a:schemeClr>
+            </a:gs>
+            <a:gs pos="50000">
+              <a:schemeClr val="phClr">
+                <a:satMod val="110000"/>
+                <a:lumMod val="100000"/>
+                <a:shade val="100000"/>
+              </a:schemeClr>
+            </a:gs>
+            <a:gs pos="100000">
+              <a:schemeClr val="phClr">
+                <a:lumMod val="99000"/>
+                <a:satMod val="120000"/>
+                <a:shade val="78000"/>
+              </a:schemeClr>
+            </a:gs>
+          </a:gsLst>
+          <a:lin ang="5400000" scaled="0"/>
+        </a:gradFill>
+      </a:fillStyleLst>
+      <a:lnStyleLst>
+        <a:ln w="12700" cap="flat" cmpd="sng" algn="ctr">
+          <a:solidFill>
+            <a:schemeClr val="phClr"/>
+          </a:solidFill>
+          <a:prstDash val="solid"/>
+          <a:miter lim="800000"/>
+        </a:ln>
+        <a:ln w="19050" cap="flat" cmpd="sng" algn="ctr">
+          <a:solidFill>
+            <a:schemeClr val="phClr"/>
+          </a:solidFill>
+          <a:prstDash val="solid"/>
+          <a:miter lim="800000"/>
+        </a:ln>
+        <a:ln w="25400" cap="flat" cmpd="sng" algn="ctr">
+          <a:solidFill>
+            <a:schemeClr val="phClr"/>
+          </a:solidFill>
+          <a:prstDash val="solid"/>
+          <a:miter lim="800000"/>
+        </a:ln>
+      </a:lnStyleLst>
+      <a:effectStyleLst>
+        <a:effectStyle>
+          <a:effectLst/>
+        </a:effectStyle>
+        <a:effectStyle>
+          <a:effectLst/>
+        </a:effectStyle>
+        <a:effectStyle>
+          <a:effectLst>
+            <a:outerShdw blurRad="57150" dist="19050" dir="5400000" algn="ctr" rotWithShape="0">
+              <a:srgbClr val="000000">
+                <a:alpha val="63000"/>
+              </a:srgbClr>
+            </a:outerShdw>
+          </a:effectLst>
+        </a:effectStyle>
+      </a:effectStyleLst>
+      <a:bgFillStyleLst>
+        <a:solidFill>
+          <a:schemeClr val="phClr"/>
+        </a:solidFill>
+        <a:solidFill>
+          <a:schemeClr val="phClr">
+            <a:tint val="95000"/>
+            <a:satMod val="170000"/>
+          </a:schemeClr>
+        </a:solidFill>
+        <a:gradFill rotWithShape="1">
+          <a:gsLst>
+            <a:gs pos="0">
+              <a:schemeClr val="phClr">
+                <a:tint val="93000"/>
+                <a:satMod val="150000"/>
+                <a:shade val="98000"/>
+                <a:lumMod val="102000"/>
+              </a:schemeClr>
+            </a:gs>
+            <a:gs pos="50000">
+              <a:schemeClr val="phClr">
+                <a:tint val="98000"/>
+                <a:satMod val="130000"/>
+                <a:shade val="90000"/>
+                <a:lumMod val="103000"/>
+              </a:schemeClr>
+            </a:gs>
+            <a:gs pos="100000">
+              <a:schemeClr val="phClr">
+                <a:shade val="63000"/>
+                <a:satMod val="120000"/>
+              </a:schemeClr>
+            </a:gs>
+          </a:gsLst>
+          <a:lin ang="5400000" scaled="0"/>
+        </a:gradFill>
+      </a:bgFillStyleLst>
+    </a:fmtScheme>
+  </a:themeElements>
+  <a:objectDefaults>
+    <a:lnDef>
+      <a:spPr/>
+      <a:bodyPr/>
+      <a:lstStyle/>
+      <a:style>
+        <a:lnRef idx="2">
+          <a:schemeClr val="accent1"/>
+        </a:lnRef>
+        <a:fillRef idx="0">
+          <a:schemeClr val="accent1"/>
+        </a:fillRef>
+        <a:effectRef idx="1">
+          <a:schemeClr val="accent1"/>
+        </a:effectRef>
+        <a:fontRef idx="minor">
+          <a:schemeClr val="tx1"/>
+        </a:fontRef>
+      </a:style>
+    </a:lnDef>
+  </a:objectDefaults>
+  <a:extraClrSchemeLst/>
+  <a:extLst>
+    <a:ext uri="{05A4C25C-085E-4340-85A3-A5531E510DB2}">
+      <thm15:themeFamily xmlns:thm15="http://schemas.microsoft.com/office/thememl/2012/main" name="Office Theme" id="{2E142A2C-CD16-42D6-873A-C26D2A0506FA}" vid="{1BDDFF52-6CD6-40A5-AB3C-68EB2F1E4D0A}"/>
+    </a:ext>
+  </a:extLst>
+</a:theme>
+</file>
+
 <file path=docMetadata/LabelInfo.xml><?xml version="1.0" encoding="utf-8"?>
 <clbl:labelList xmlns:clbl="http://schemas.microsoft.com/office/2020/mipLabelMetadata">
   <clbl:label id="{cf8c7287-838c-46dd-b281-b1140229e67a}" enabled="1" method="Privileged" siteId="{75e027c9-20d5-47d5-b82f-77d7cd041e8f}" removed="0"/>

</xml_diff>